<commit_message>
finish three slides prompt
</commit_message>
<xml_diff>
--- a/example_files/example slides.pptx
+++ b/example_files/example slides.pptx
@@ -207,7 +207,7 @@
           <a:p>
             <a:fld id="{41114AA6-83B2-48B3-ADA3-54A34F936A3E}" type="datetimeFigureOut">
               <a:rPr lang="en-US" smtClean="0"/>
-              <a:t>2/27/2026</a:t>
+              <a:t>3/2/2026</a:t>
             </a:fld>
             <a:endParaRPr lang="en-US"/>
           </a:p>
@@ -25452,7 +25452,13 @@
           <p:cNvGraphicFramePr>
             <a:graphicFrameLocks noGrp="1"/>
           </p:cNvGraphicFramePr>
-          <p:nvPr/>
+          <p:nvPr>
+            <p:extLst>
+              <p:ext uri="{D42A27DB-BD31-4B8C-83A1-F6EECF244321}">
+                <p14:modId xmlns:p14="http://schemas.microsoft.com/office/powerpoint/2010/main" val="1564183880"/>
+              </p:ext>
+            </p:extLst>
+          </p:nvPr>
         </p:nvGraphicFramePr>
         <p:xfrm>
           <a:off x="431529" y="1299801"/>
@@ -25660,7 +25666,7 @@
                     <a:lstStyle/>
                     <a:p>
                       <a:r>
-                        <a:rPr lang="en-US" sz="1800" b="1">
+                        <a:rPr lang="en-US" sz="1800" b="1" dirty="0">
                           <a:solidFill>
                             <a:srgbClr val="BE2BBB"/>
                           </a:solidFill>
@@ -25670,7 +25676,7 @@
                         </a:rPr>
                         <a:t>Target/Prioritized Segment</a:t>
                       </a:r>
-                      <a:endParaRPr lang="en-US" sz="1800" b="1" i="1">
+                      <a:endParaRPr lang="en-US" sz="1800" b="1" i="1" dirty="0">
                         <a:solidFill>
                           <a:srgbClr val="595454"/>
                         </a:solidFill>
@@ -25835,7 +25841,7 @@
                     <a:lstStyle/>
                     <a:p>
                       <a:r>
-                        <a:rPr lang="en-US" sz="1800" b="1">
+                        <a:rPr lang="en-US" sz="1800" b="1" dirty="0">
                           <a:solidFill>
                             <a:srgbClr val="BE2BBB"/>
                           </a:solidFill>
@@ -25845,7 +25851,7 @@
                         </a:rPr>
                         <a:t>Drivers/Barriers</a:t>
                       </a:r>
-                      <a:endParaRPr lang="en-US" sz="1800" b="1" i="1">
+                      <a:endParaRPr lang="en-US" sz="1800" b="1" i="1" dirty="0">
                         <a:solidFill>
                           <a:srgbClr val="595454"/>
                         </a:solidFill>
@@ -26273,7 +26279,7 @@
                     <a:lstStyle/>
                     <a:p>
                       <a:pPr algn="ctr"/>
-                      <a:endParaRPr lang="en-US" sz="1200" i="1">
+                      <a:endParaRPr lang="en-US" sz="1200" i="1" dirty="0">
                         <a:solidFill>
                           <a:srgbClr val="595454"/>
                         </a:solidFill>
@@ -26325,18 +26331,17 @@
                     <a:bodyPr/>
                     <a:lstStyle/>
                     <a:p>
-                      <a:endParaRPr lang="en-US" sz="900" i="1">
+                      <a:pPr algn="ctr"/>
+                      <a:endParaRPr lang="en-US" sz="1200" i="1" dirty="0">
                         <a:solidFill>
                           <a:srgbClr val="595454"/>
                         </a:solidFill>
                       </a:endParaRPr>
                     </a:p>
                   </a:txBody>
-                  <a:tcPr marL="76002" marR="76002" marT="38001" marB="38001">
+                  <a:tcPr marL="83602" marR="83602" marT="41801" marB="41801" anchor="ctr">
                     <a:lnL w="3175" cap="flat" cmpd="sng" algn="ctr">
-                      <a:solidFill>
-                        <a:srgbClr val="A69F9F"/>
-                      </a:solidFill>
+                      <a:noFill/>
                       <a:prstDash val="solid"/>
                       <a:round/>
                       <a:headEnd type="none" w="med" len="med"/>
@@ -26450,7 +26455,7 @@
                     <a:bodyPr/>
                     <a:lstStyle/>
                     <a:p>
-                      <a:endParaRPr lang="en-US" sz="1200" i="1">
+                      <a:endParaRPr lang="en-US" sz="1200" i="1" dirty="0">
                         <a:solidFill>
                           <a:srgbClr val="595454"/>
                         </a:solidFill>
@@ -26502,18 +26507,16 @@
                     <a:bodyPr/>
                     <a:lstStyle/>
                     <a:p>
-                      <a:endParaRPr lang="en-US" sz="900" i="1">
+                      <a:endParaRPr lang="en-US" sz="1200" i="1" dirty="0">
                         <a:solidFill>
                           <a:srgbClr val="595454"/>
                         </a:solidFill>
                       </a:endParaRPr>
                     </a:p>
                   </a:txBody>
-                  <a:tcPr marL="76002" marR="76002" marT="38001" marB="38001" anchor="ctr">
+                  <a:tcPr marL="83602" marR="83602" marT="41801" marB="41801" anchor="ctr">
                     <a:lnL w="3175" cap="flat" cmpd="sng" algn="ctr">
-                      <a:solidFill>
-                        <a:srgbClr val="A69F9F"/>
-                      </a:solidFill>
+                      <a:noFill/>
                       <a:prstDash val="solid"/>
                       <a:round/>
                       <a:headEnd type="none" w="med" len="med"/>
@@ -26642,7 +26645,7 @@
                     <a:bodyPr/>
                     <a:lstStyle/>
                     <a:p>
-                      <a:endParaRPr lang="en-US" sz="1200" i="1">
+                      <a:endParaRPr lang="en-US" sz="1200" i="1" dirty="0">
                         <a:solidFill>
                           <a:srgbClr val="595454"/>
                         </a:solidFill>
@@ -26694,7 +26697,7 @@
                     <a:bodyPr/>
                     <a:lstStyle/>
                     <a:p>
-                      <a:endParaRPr lang="en-US" sz="1200" i="1">
+                      <a:endParaRPr lang="en-US" sz="1200" i="1" dirty="0">
                         <a:solidFill>
                           <a:srgbClr val="595454"/>
                         </a:solidFill>
@@ -27462,21 +27465,12 @@
 </file>
 
 <file path=customXml/item1.xml><?xml version="1.0" encoding="utf-8"?>
-<p:properties xmlns:p="http://schemas.microsoft.com/office/2006/metadata/properties" xmlns:xsi="http://www.w3.org/2001/XMLSchema-instance" xmlns:pc="http://schemas.microsoft.com/office/infopath/2007/PartnerControls">
-  <documentManagement>
-    <TaxCatchAll xmlns="1ff81937-46f0-48f5-a4f4-7207cfde9880" xsi:nil="true"/>
-    <SharedWithUsers xmlns="1ff81937-46f0-48f5-a4f4-7207cfde9880">
-      <UserInfo>
-        <DisplayName>Kaplan, Lori</DisplayName>
-        <AccountId>27</AccountId>
-        <AccountType/>
-      </UserInfo>
-    </SharedWithUsers>
-    <lcf76f155ced4ddcb4097134ff3c332f xmlns="d58aa00e-f3c0-46ab-a6c5-a4aa8ec7276e">
-      <Terms xmlns="http://schemas.microsoft.com/office/infopath/2007/PartnerControls"/>
-    </lcf76f155ced4ddcb4097134ff3c332f>
-  </documentManagement>
-</p:properties>
+<?mso-contentType ?>
+<FormTemplates xmlns="http://schemas.microsoft.com/sharepoint/v3/contenttype/forms">
+  <Display>DocumentLibraryForm</Display>
+  <Edit>DocumentLibraryForm</Edit>
+  <New>DocumentLibraryForm</New>
+</FormTemplates>
 </file>
 
 <file path=customXml/item2.xml><?xml version="1.0" encoding="utf-8"?>
@@ -27701,28 +27695,27 @@
 </file>
 
 <file path=customXml/item3.xml><?xml version="1.0" encoding="utf-8"?>
-<?mso-contentType ?>
-<FormTemplates xmlns="http://schemas.microsoft.com/sharepoint/v3/contenttype/forms">
-  <Display>DocumentLibraryForm</Display>
-  <Edit>DocumentLibraryForm</Edit>
-  <New>DocumentLibraryForm</New>
-</FormTemplates>
+<p:properties xmlns:p="http://schemas.microsoft.com/office/2006/metadata/properties" xmlns:xsi="http://www.w3.org/2001/XMLSchema-instance" xmlns:pc="http://schemas.microsoft.com/office/infopath/2007/PartnerControls">
+  <documentManagement>
+    <TaxCatchAll xmlns="1ff81937-46f0-48f5-a4f4-7207cfde9880" xsi:nil="true"/>
+    <SharedWithUsers xmlns="1ff81937-46f0-48f5-a4f4-7207cfde9880">
+      <UserInfo>
+        <DisplayName>Kaplan, Lori</DisplayName>
+        <AccountId>27</AccountId>
+        <AccountType/>
+      </UserInfo>
+    </SharedWithUsers>
+    <lcf76f155ced4ddcb4097134ff3c332f xmlns="d58aa00e-f3c0-46ab-a6c5-a4aa8ec7276e">
+      <Terms xmlns="http://schemas.microsoft.com/office/infopath/2007/PartnerControls"/>
+    </lcf76f155ced4ddcb4097134ff3c332f>
+  </documentManagement>
+</p:properties>
 </file>
 
 <file path=customXml/itemProps1.xml><?xml version="1.0" encoding="utf-8"?>
-<ds:datastoreItem xmlns:ds="http://schemas.openxmlformats.org/officeDocument/2006/customXml" ds:itemID="{6B059CB1-CB57-45C8-B58C-EB9957E73A5D}">
+<ds:datastoreItem xmlns:ds="http://schemas.openxmlformats.org/officeDocument/2006/customXml" ds:itemID="{A2F406D8-50A4-457E-B611-78758F79527B}">
   <ds:schemaRefs>
-    <ds:schemaRef ds:uri="1ff81937-46f0-48f5-a4f4-7207cfde9880"/>
-    <ds:schemaRef ds:uri="4ce1936b-43e3-436c-964a-a212a0edf4f1"/>
-    <ds:schemaRef ds:uri="d58aa00e-f3c0-46ab-a6c5-a4aa8ec7276e"/>
-    <ds:schemaRef ds:uri="http://purl.org/dc/dcmitype/"/>
-    <ds:schemaRef ds:uri="http://purl.org/dc/elements/1.1/"/>
-    <ds:schemaRef ds:uri="http://purl.org/dc/terms/"/>
-    <ds:schemaRef ds:uri="http://schemas.microsoft.com/office/2006/documentManagement/types"/>
-    <ds:schemaRef ds:uri="http://schemas.microsoft.com/office/2006/metadata/properties"/>
-    <ds:schemaRef ds:uri="http://schemas.microsoft.com/office/infopath/2007/PartnerControls"/>
-    <ds:schemaRef ds:uri="http://schemas.openxmlformats.org/package/2006/metadata/core-properties"/>
-    <ds:schemaRef ds:uri="http://www.w3.org/XML/1998/namespace"/>
+    <ds:schemaRef ds:uri="http://schemas.microsoft.com/sharepoint/v3/contenttype/forms"/>
   </ds:schemaRefs>
 </ds:datastoreItem>
 </file>
@@ -27747,9 +27740,19 @@
 </file>
 
 <file path=customXml/itemProps3.xml><?xml version="1.0" encoding="utf-8"?>
-<ds:datastoreItem xmlns:ds="http://schemas.openxmlformats.org/officeDocument/2006/customXml" ds:itemID="{A2F406D8-50A4-457E-B611-78758F79527B}">
+<ds:datastoreItem xmlns:ds="http://schemas.openxmlformats.org/officeDocument/2006/customXml" ds:itemID="{6B059CB1-CB57-45C8-B58C-EB9957E73A5D}">
   <ds:schemaRefs>
-    <ds:schemaRef ds:uri="http://schemas.microsoft.com/sharepoint/v3/contenttype/forms"/>
+    <ds:schemaRef ds:uri="1ff81937-46f0-48f5-a4f4-7207cfde9880"/>
+    <ds:schemaRef ds:uri="4ce1936b-43e3-436c-964a-a212a0edf4f1"/>
+    <ds:schemaRef ds:uri="d58aa00e-f3c0-46ab-a6c5-a4aa8ec7276e"/>
+    <ds:schemaRef ds:uri="http://purl.org/dc/dcmitype/"/>
+    <ds:schemaRef ds:uri="http://purl.org/dc/elements/1.1/"/>
+    <ds:schemaRef ds:uri="http://purl.org/dc/terms/"/>
+    <ds:schemaRef ds:uri="http://schemas.microsoft.com/office/2006/documentManagement/types"/>
+    <ds:schemaRef ds:uri="http://schemas.microsoft.com/office/2006/metadata/properties"/>
+    <ds:schemaRef ds:uri="http://schemas.microsoft.com/office/infopath/2007/PartnerControls"/>
+    <ds:schemaRef ds:uri="http://schemas.openxmlformats.org/package/2006/metadata/core-properties"/>
+    <ds:schemaRef ds:uri="http://www.w3.org/XML/1998/namespace"/>
   </ds:schemaRefs>
 </ds:datastoreItem>
 </file>

</xml_diff>

<commit_message>
demo v4 ready version
</commit_message>
<xml_diff>
--- a/example_files/example slides.pptx
+++ b/example_files/example slides.pptx
@@ -5,14 +5,16 @@
     <p:sldMasterId id="2147483660" r:id="rId4"/>
   </p:sldMasterIdLst>
   <p:notesMasterIdLst>
-    <p:notesMasterId r:id="rId10"/>
+    <p:notesMasterId r:id="rId12"/>
   </p:notesMasterIdLst>
   <p:sldIdLst>
     <p:sldId id="2147483481" r:id="rId5"/>
     <p:sldId id="272" r:id="rId6"/>
     <p:sldId id="2147483474" r:id="rId7"/>
     <p:sldId id="2147483487" r:id="rId8"/>
-    <p:sldId id="2147483541" r:id="rId9"/>
+    <p:sldId id="2032093144" r:id="rId9"/>
+    <p:sldId id="2147483542" r:id="rId10"/>
+    <p:sldId id="2147483541" r:id="rId11"/>
   </p:sldIdLst>
   <p:sldSz cx="12192000" cy="6858000"/>
   <p:notesSz cx="6858000" cy="9144000"/>
@@ -207,7 +209,7 @@
           <a:p>
             <a:fld id="{41114AA6-83B2-48B3-ADA3-54A34F936A3E}" type="datetimeFigureOut">
               <a:rPr lang="en-US" smtClean="0"/>
-              <a:t>3/2/2026</a:t>
+              <a:t>3/11/2026</a:t>
             </a:fld>
             <a:endParaRPr lang="en-US"/>
           </a:p>
@@ -859,7 +861,7 @@
                 <a:tabLst/>
                 <a:defRPr/>
               </a:pPr>
-              <a:t>5</a:t>
+              <a:t>7</a:t>
             </a:fld>
             <a:endParaRPr kumimoji="0" lang="en-US" sz="1200" b="0" i="0" u="none" strike="noStrike" kern="1200" cap="none" spc="0" normalizeH="0" baseline="0" noProof="0">
               <a:ln>
@@ -25229,14 +25231,7 @@
           <a:p>
             <a:r>
               <a:rPr lang="en-US" dirty="0"/>
-              <a:t>Messaging</a:t>
-            </a:r>
-            <a:br>
-              <a:rPr lang="en-US" dirty="0"/>
-            </a:br>
-            <a:r>
-              <a:rPr lang="en-US" dirty="0"/>
-              <a:t>Strategy</a:t>
+              <a:t>SWOT Analysis</a:t>
             </a:r>
           </a:p>
         </p:txBody>
@@ -25296,6 +25291,917 @@
 </file>
 
 <file path=ppt/slides/slide5.xml><?xml version="1.0" encoding="utf-8"?>
+<p:sld xmlns:a="http://schemas.openxmlformats.org/drawingml/2006/main" xmlns:r="http://schemas.openxmlformats.org/officeDocument/2006/relationships" xmlns:p="http://schemas.openxmlformats.org/presentationml/2006/main">
+  <p:cSld>
+    <p:spTree>
+      <p:nvGrpSpPr>
+        <p:cNvPr id="1" name="">
+          <a:extLst>
+            <a:ext uri="{FF2B5EF4-FFF2-40B4-BE49-F238E27FC236}">
+              <a16:creationId xmlns:a16="http://schemas.microsoft.com/office/drawing/2014/main" id="{5CA6A10E-3EC0-FD24-3FEF-80972A962D3D}"/>
+            </a:ext>
+          </a:extLst>
+        </p:cNvPr>
+        <p:cNvGrpSpPr/>
+        <p:nvPr/>
+      </p:nvGrpSpPr>
+      <p:grpSpPr>
+        <a:xfrm>
+          <a:off x="0" y="0"/>
+          <a:ext cx="0" cy="0"/>
+          <a:chOff x="0" y="0"/>
+          <a:chExt cx="0" cy="0"/>
+        </a:xfrm>
+      </p:grpSpPr>
+      <p:sp>
+        <p:nvSpPr>
+          <p:cNvPr id="2" name="Title 1">
+            <a:extLst>
+              <a:ext uri="{FF2B5EF4-FFF2-40B4-BE49-F238E27FC236}">
+                <a16:creationId xmlns:a16="http://schemas.microsoft.com/office/drawing/2014/main" id="{9DADC100-07D5-00E4-8DB3-CB6E44AAC2ED}"/>
+              </a:ext>
+            </a:extLst>
+          </p:cNvPr>
+          <p:cNvSpPr>
+            <a:spLocks noGrp="1"/>
+          </p:cNvSpPr>
+          <p:nvPr>
+            <p:ph type="title"/>
+          </p:nvPr>
+        </p:nvSpPr>
+        <p:spPr bwMode="gray">
+          <a:xfrm>
+            <a:off x="548640" y="429768"/>
+            <a:ext cx="11091672" cy="984885"/>
+          </a:xfrm>
+        </p:spPr>
+        <p:txBody>
+          <a:bodyPr/>
+          <a:lstStyle/>
+          <a:p>
+            <a:r>
+              <a:rPr lang="en-US" dirty="0"/>
+              <a:t>SWOT</a:t>
+            </a:r>
+          </a:p>
+        </p:txBody>
+      </p:sp>
+      <p:graphicFrame>
+        <p:nvGraphicFramePr>
+          <p:cNvPr id="8" name="Table 7">
+            <a:extLst>
+              <a:ext uri="{FF2B5EF4-FFF2-40B4-BE49-F238E27FC236}">
+                <a16:creationId xmlns:a16="http://schemas.microsoft.com/office/drawing/2014/main" id="{5CF0DAC7-5061-A54D-9BBB-AAC06B0055EC}"/>
+              </a:ext>
+            </a:extLst>
+          </p:cNvPr>
+          <p:cNvGraphicFramePr>
+            <a:graphicFrameLocks noGrp="1"/>
+          </p:cNvGraphicFramePr>
+          <p:nvPr/>
+        </p:nvGraphicFramePr>
+        <p:xfrm>
+          <a:off x="548639" y="1907118"/>
+          <a:ext cx="11091672" cy="4389120"/>
+        </p:xfrm>
+        <a:graphic>
+          <a:graphicData uri="http://schemas.openxmlformats.org/drawingml/2006/table">
+            <a:tbl>
+              <a:tblPr firstRow="1" bandRow="1">
+                <a:tableStyleId>{5C22544A-7EE6-4342-B048-85BDC9FD1C3A}</a:tableStyleId>
+              </a:tblPr>
+              <a:tblGrid>
+                <a:gridCol w="2772918">
+                  <a:extLst>
+                    <a:ext uri="{9D8B030D-6E8A-4147-A177-3AD203B41FA5}">
+                      <a16:colId xmlns:a16="http://schemas.microsoft.com/office/drawing/2014/main" val="1322876460"/>
+                    </a:ext>
+                  </a:extLst>
+                </a:gridCol>
+                <a:gridCol w="2772918">
+                  <a:extLst>
+                    <a:ext uri="{9D8B030D-6E8A-4147-A177-3AD203B41FA5}">
+                      <a16:colId xmlns:a16="http://schemas.microsoft.com/office/drawing/2014/main" val="2009499124"/>
+                    </a:ext>
+                  </a:extLst>
+                </a:gridCol>
+                <a:gridCol w="2772918">
+                  <a:extLst>
+                    <a:ext uri="{9D8B030D-6E8A-4147-A177-3AD203B41FA5}">
+                      <a16:colId xmlns:a16="http://schemas.microsoft.com/office/drawing/2014/main" val="490926120"/>
+                    </a:ext>
+                  </a:extLst>
+                </a:gridCol>
+                <a:gridCol w="2772918">
+                  <a:extLst>
+                    <a:ext uri="{9D8B030D-6E8A-4147-A177-3AD203B41FA5}">
+                      <a16:colId xmlns:a16="http://schemas.microsoft.com/office/drawing/2014/main" val="324268400"/>
+                    </a:ext>
+                  </a:extLst>
+                </a:gridCol>
+              </a:tblGrid>
+              <a:tr h="914400">
+                <a:tc>
+                  <a:txBody>
+                    <a:bodyPr/>
+                    <a:lstStyle/>
+                    <a:p>
+                      <a:pPr marL="0" marR="0" lvl="0" indent="0" algn="ctr" defTabSz="914400" rtl="0" eaLnBrk="1" fontAlgn="auto" latinLnBrk="0" hangingPunct="1">
+                        <a:lnSpc>
+                          <a:spcPct val="100000"/>
+                        </a:lnSpc>
+                        <a:spcBef>
+                          <a:spcPts val="0"/>
+                        </a:spcBef>
+                        <a:spcAft>
+                          <a:spcPts val="0"/>
+                        </a:spcAft>
+                        <a:buClrTx/>
+                        <a:buSzTx/>
+                        <a:buFontTx/>
+                        <a:buNone/>
+                        <a:tabLst/>
+                        <a:defRPr/>
+                      </a:pPr>
+                      <a:r>
+                        <a:rPr lang="en-US" sz="2000" b="1" dirty="0">
+                          <a:solidFill>
+                            <a:schemeClr val="tx1"/>
+                          </a:solidFill>
+                        </a:rPr>
+                        <a:t>Strengths</a:t>
+                      </a:r>
+                    </a:p>
+                  </a:txBody>
+                  <a:tcPr marB="91440" anchor="b">
+                    <a:lnL w="12700" cmpd="sng">
+                      <a:noFill/>
+                    </a:lnL>
+                    <a:lnR w="12700" cmpd="sng">
+                      <a:noFill/>
+                    </a:lnR>
+                    <a:lnT w="12700" cmpd="sng">
+                      <a:noFill/>
+                    </a:lnT>
+                    <a:lnB w="38100" cmpd="sng">
+                      <a:noFill/>
+                    </a:lnB>
+                    <a:lnTlToBr w="12700" cmpd="sng">
+                      <a:noFill/>
+                      <a:prstDash val="solid"/>
+                    </a:lnTlToBr>
+                    <a:lnBlToTr w="12700" cmpd="sng">
+                      <a:noFill/>
+                      <a:prstDash val="solid"/>
+                    </a:lnBlToTr>
+                    <a:solidFill>
+                      <a:schemeClr val="accent2">
+                        <a:lumMod val="20000"/>
+                        <a:lumOff val="80000"/>
+                      </a:schemeClr>
+                    </a:solidFill>
+                  </a:tcPr>
+                </a:tc>
+                <a:tc>
+                  <a:txBody>
+                    <a:bodyPr/>
+                    <a:lstStyle/>
+                    <a:p>
+                      <a:pPr marL="0" marR="0" lvl="0" indent="0" algn="ctr" defTabSz="914400" rtl="0" eaLnBrk="1" fontAlgn="auto" latinLnBrk="0" hangingPunct="1">
+                        <a:lnSpc>
+                          <a:spcPct val="100000"/>
+                        </a:lnSpc>
+                        <a:spcBef>
+                          <a:spcPts val="0"/>
+                        </a:spcBef>
+                        <a:spcAft>
+                          <a:spcPts val="0"/>
+                        </a:spcAft>
+                        <a:buClrTx/>
+                        <a:buSzTx/>
+                        <a:buFontTx/>
+                        <a:buNone/>
+                        <a:tabLst/>
+                        <a:defRPr/>
+                      </a:pPr>
+                      <a:r>
+                        <a:rPr lang="en-US" sz="2000" b="1" dirty="0">
+                          <a:solidFill>
+                            <a:schemeClr val="tx1"/>
+                          </a:solidFill>
+                        </a:rPr>
+                        <a:t>Weaknesses</a:t>
+                      </a:r>
+                    </a:p>
+                  </a:txBody>
+                  <a:tcPr marB="91440" anchor="b">
+                    <a:lnL w="12700" cmpd="sng">
+                      <a:noFill/>
+                    </a:lnL>
+                    <a:lnR w="12700" cmpd="sng">
+                      <a:noFill/>
+                    </a:lnR>
+                    <a:lnT w="12700" cmpd="sng">
+                      <a:noFill/>
+                    </a:lnT>
+                    <a:lnB w="38100" cmpd="sng">
+                      <a:noFill/>
+                    </a:lnB>
+                    <a:lnTlToBr w="12700" cmpd="sng">
+                      <a:noFill/>
+                      <a:prstDash val="solid"/>
+                    </a:lnTlToBr>
+                    <a:lnBlToTr w="12700" cmpd="sng">
+                      <a:noFill/>
+                      <a:prstDash val="solid"/>
+                    </a:lnBlToTr>
+                    <a:solidFill>
+                      <a:srgbClr val="EEE7E7"/>
+                    </a:solidFill>
+                  </a:tcPr>
+                </a:tc>
+                <a:tc>
+                  <a:txBody>
+                    <a:bodyPr/>
+                    <a:lstStyle/>
+                    <a:p>
+                      <a:pPr marL="0" marR="0" lvl="0" indent="0" algn="ctr" defTabSz="914400" rtl="0" eaLnBrk="1" fontAlgn="auto" latinLnBrk="0" hangingPunct="1">
+                        <a:lnSpc>
+                          <a:spcPct val="100000"/>
+                        </a:lnSpc>
+                        <a:spcBef>
+                          <a:spcPts val="0"/>
+                        </a:spcBef>
+                        <a:spcAft>
+                          <a:spcPts val="0"/>
+                        </a:spcAft>
+                        <a:buClrTx/>
+                        <a:buSzTx/>
+                        <a:buFontTx/>
+                        <a:buNone/>
+                        <a:tabLst/>
+                        <a:defRPr/>
+                      </a:pPr>
+                      <a:r>
+                        <a:rPr lang="en-US" sz="2000" b="1" kern="1200" dirty="0">
+                          <a:solidFill>
+                            <a:schemeClr val="tx1"/>
+                          </a:solidFill>
+                          <a:latin typeface="+mn-lt"/>
+                          <a:ea typeface="+mn-ea"/>
+                          <a:cs typeface="+mn-cs"/>
+                        </a:rPr>
+                        <a:t>Opportunities</a:t>
+                      </a:r>
+                    </a:p>
+                  </a:txBody>
+                  <a:tcPr marB="91440" anchor="b">
+                    <a:lnL w="12700" cmpd="sng">
+                      <a:noFill/>
+                    </a:lnL>
+                    <a:lnR w="12700" cmpd="sng">
+                      <a:noFill/>
+                    </a:lnR>
+                    <a:lnT w="12700" cmpd="sng">
+                      <a:noFill/>
+                    </a:lnT>
+                    <a:lnB w="38100" cmpd="sng">
+                      <a:noFill/>
+                    </a:lnB>
+                    <a:lnTlToBr w="12700" cmpd="sng">
+                      <a:noFill/>
+                      <a:prstDash val="solid"/>
+                    </a:lnTlToBr>
+                    <a:lnBlToTr w="12700" cmpd="sng">
+                      <a:noFill/>
+                      <a:prstDash val="solid"/>
+                    </a:lnBlToTr>
+                    <a:solidFill>
+                      <a:schemeClr val="accent2">
+                        <a:lumMod val="20000"/>
+                        <a:lumOff val="80000"/>
+                      </a:schemeClr>
+                    </a:solidFill>
+                  </a:tcPr>
+                </a:tc>
+                <a:tc>
+                  <a:txBody>
+                    <a:bodyPr/>
+                    <a:lstStyle/>
+                    <a:p>
+                      <a:pPr marL="0" marR="0" lvl="0" indent="0" algn="ctr" defTabSz="914400" rtl="0" eaLnBrk="1" fontAlgn="auto" latinLnBrk="0" hangingPunct="1">
+                        <a:lnSpc>
+                          <a:spcPct val="100000"/>
+                        </a:lnSpc>
+                        <a:spcBef>
+                          <a:spcPts val="0"/>
+                        </a:spcBef>
+                        <a:spcAft>
+                          <a:spcPts val="0"/>
+                        </a:spcAft>
+                        <a:buClrTx/>
+                        <a:buSzTx/>
+                        <a:buFontTx/>
+                        <a:buNone/>
+                        <a:tabLst/>
+                        <a:defRPr/>
+                      </a:pPr>
+                      <a:r>
+                        <a:rPr lang="en-US" sz="2000" b="1" kern="1200" dirty="0">
+                          <a:solidFill>
+                            <a:schemeClr val="tx1"/>
+                          </a:solidFill>
+                          <a:latin typeface="+mn-lt"/>
+                          <a:ea typeface="+mn-ea"/>
+                          <a:cs typeface="+mn-cs"/>
+                        </a:rPr>
+                        <a:t>Threats</a:t>
+                      </a:r>
+                    </a:p>
+                  </a:txBody>
+                  <a:tcPr marB="91440" anchor="b">
+                    <a:lnL w="12700" cmpd="sng">
+                      <a:noFill/>
+                    </a:lnL>
+                    <a:lnR w="12700" cmpd="sng">
+                      <a:noFill/>
+                    </a:lnR>
+                    <a:lnT w="12700" cmpd="sng">
+                      <a:noFill/>
+                    </a:lnT>
+                    <a:lnB w="38100" cmpd="sng">
+                      <a:noFill/>
+                    </a:lnB>
+                    <a:lnTlToBr w="12700" cmpd="sng">
+                      <a:noFill/>
+                      <a:prstDash val="solid"/>
+                    </a:lnTlToBr>
+                    <a:lnBlToTr w="12700" cmpd="sng">
+                      <a:noFill/>
+                      <a:prstDash val="solid"/>
+                    </a:lnBlToTr>
+                    <a:solidFill>
+                      <a:srgbClr val="EEE7E7"/>
+                    </a:solidFill>
+                  </a:tcPr>
+                </a:tc>
+                <a:extLst>
+                  <a:ext uri="{0D108BD9-81ED-4DB2-BD59-A6C34878D82A}">
+                    <a16:rowId xmlns:a16="http://schemas.microsoft.com/office/drawing/2014/main" val="124223165"/>
+                  </a:ext>
+                </a:extLst>
+              </a:tr>
+              <a:tr h="3474720">
+                <a:tc>
+                  <a:txBody>
+                    <a:bodyPr/>
+                    <a:lstStyle/>
+                    <a:p>
+                      <a:pPr algn="ctr"/>
+                      <a:endParaRPr lang="en-US" sz="1400" dirty="0">
+                        <a:solidFill>
+                          <a:schemeClr val="tx1"/>
+                        </a:solidFill>
+                      </a:endParaRPr>
+                    </a:p>
+                  </a:txBody>
+                  <a:tcPr anchor="ctr">
+                    <a:lnT w="38100" cmpd="sng">
+                      <a:noFill/>
+                    </a:lnT>
+                    <a:solidFill>
+                      <a:schemeClr val="accent2">
+                        <a:lumMod val="20000"/>
+                        <a:lumOff val="80000"/>
+                      </a:schemeClr>
+                    </a:solidFill>
+                  </a:tcPr>
+                </a:tc>
+                <a:tc>
+                  <a:txBody>
+                    <a:bodyPr/>
+                    <a:lstStyle/>
+                    <a:p>
+                      <a:pPr algn="ctr"/>
+                      <a:endParaRPr lang="en-US" sz="1400" dirty="0">
+                        <a:solidFill>
+                          <a:schemeClr val="tx1"/>
+                        </a:solidFill>
+                      </a:endParaRPr>
+                    </a:p>
+                  </a:txBody>
+                  <a:tcPr anchor="ctr">
+                    <a:lnT w="38100" cmpd="sng">
+                      <a:noFill/>
+                    </a:lnT>
+                    <a:solidFill>
+                      <a:srgbClr val="EEE7E7"/>
+                    </a:solidFill>
+                  </a:tcPr>
+                </a:tc>
+                <a:tc>
+                  <a:txBody>
+                    <a:bodyPr/>
+                    <a:lstStyle/>
+                    <a:p>
+                      <a:pPr algn="ctr"/>
+                      <a:endParaRPr lang="en-US" sz="1400" dirty="0">
+                        <a:solidFill>
+                          <a:schemeClr val="tx1"/>
+                        </a:solidFill>
+                      </a:endParaRPr>
+                    </a:p>
+                  </a:txBody>
+                  <a:tcPr anchor="ctr">
+                    <a:lnT w="38100" cmpd="sng">
+                      <a:noFill/>
+                    </a:lnT>
+                    <a:solidFill>
+                      <a:schemeClr val="accent2">
+                        <a:lumMod val="20000"/>
+                        <a:lumOff val="80000"/>
+                      </a:schemeClr>
+                    </a:solidFill>
+                  </a:tcPr>
+                </a:tc>
+                <a:tc>
+                  <a:txBody>
+                    <a:bodyPr/>
+                    <a:lstStyle/>
+                    <a:p>
+                      <a:pPr algn="ctr"/>
+                      <a:endParaRPr lang="en-US" sz="1400" dirty="0">
+                        <a:solidFill>
+                          <a:schemeClr val="tx1"/>
+                        </a:solidFill>
+                      </a:endParaRPr>
+                    </a:p>
+                  </a:txBody>
+                  <a:tcPr anchor="ctr">
+                    <a:lnT w="38100" cmpd="sng">
+                      <a:noFill/>
+                    </a:lnT>
+                    <a:solidFill>
+                      <a:srgbClr val="EEE7E7"/>
+                    </a:solidFill>
+                  </a:tcPr>
+                </a:tc>
+                <a:extLst>
+                  <a:ext uri="{0D108BD9-81ED-4DB2-BD59-A6C34878D82A}">
+                    <a16:rowId xmlns:a16="http://schemas.microsoft.com/office/drawing/2014/main" val="2274849163"/>
+                  </a:ext>
+                </a:extLst>
+              </a:tr>
+            </a:tbl>
+          </a:graphicData>
+        </a:graphic>
+      </p:graphicFrame>
+      <p:sp>
+        <p:nvSpPr>
+          <p:cNvPr id="20" name="Oval 19">
+            <a:extLst>
+              <a:ext uri="{FF2B5EF4-FFF2-40B4-BE49-F238E27FC236}">
+                <a16:creationId xmlns:a16="http://schemas.microsoft.com/office/drawing/2014/main" id="{ED62D64A-5E66-A2A8-298B-8F3014CD8CE9}"/>
+              </a:ext>
+            </a:extLst>
+          </p:cNvPr>
+          <p:cNvSpPr>
+            <a:spLocks/>
+          </p:cNvSpPr>
+          <p:nvPr/>
+        </p:nvSpPr>
+        <p:spPr bwMode="gray">
+          <a:xfrm>
+            <a:off x="9795149" y="1388958"/>
+            <a:ext cx="914400" cy="914400"/>
+          </a:xfrm>
+          <a:prstGeom prst="ellipse">
+            <a:avLst/>
+          </a:prstGeom>
+          <a:solidFill>
+            <a:srgbClr val="F4F3F3"/>
+          </a:solidFill>
+          <a:ln w="12700">
+            <a:noFill/>
+          </a:ln>
+        </p:spPr>
+        <p:style>
+          <a:lnRef idx="2">
+            <a:schemeClr val="accent1">
+              <a:shade val="50000"/>
+            </a:schemeClr>
+          </a:lnRef>
+          <a:fillRef idx="1">
+            <a:schemeClr val="accent1"/>
+          </a:fillRef>
+          <a:effectRef idx="0">
+            <a:schemeClr val="accent1"/>
+          </a:effectRef>
+          <a:fontRef idx="minor">
+            <a:schemeClr val="lt1"/>
+          </a:fontRef>
+        </p:style>
+        <p:txBody>
+          <a:bodyPr rot="0" spcFirstLastPara="0" vertOverflow="overflow" horzOverflow="overflow" vert="horz" wrap="square" lIns="91440" tIns="91440" rIns="91440" bIns="91440" numCol="1" spcCol="0" rtlCol="0" fromWordArt="0" anchor="ctr" anchorCtr="0" forceAA="0" compatLnSpc="1">
+            <a:prstTxWarp prst="textNoShape">
+              <a:avLst/>
+            </a:prstTxWarp>
+            <a:noAutofit/>
+          </a:bodyPr>
+          <a:lstStyle/>
+          <a:p>
+            <a:pPr algn="ctr">
+              <a:spcBef>
+                <a:spcPts val="1500"/>
+              </a:spcBef>
+              <a:spcAft>
+                <a:spcPts val="0"/>
+              </a:spcAft>
+            </a:pPr>
+            <a:r>
+              <a:rPr lang="en-US" sz="2800" b="1" dirty="0">
+                <a:solidFill>
+                  <a:srgbClr val="BE2BBB"/>
+                </a:solidFill>
+              </a:rPr>
+              <a:t>T</a:t>
+            </a:r>
+          </a:p>
+        </p:txBody>
+      </p:sp>
+      <p:sp>
+        <p:nvSpPr>
+          <p:cNvPr id="3" name="Oval 2">
+            <a:extLst>
+              <a:ext uri="{FF2B5EF4-FFF2-40B4-BE49-F238E27FC236}">
+                <a16:creationId xmlns:a16="http://schemas.microsoft.com/office/drawing/2014/main" id="{F90431C2-B9D0-EAE7-9B3A-BA9CF469249F}"/>
+              </a:ext>
+            </a:extLst>
+          </p:cNvPr>
+          <p:cNvSpPr>
+            <a:spLocks/>
+          </p:cNvSpPr>
+          <p:nvPr/>
+        </p:nvSpPr>
+        <p:spPr bwMode="gray">
+          <a:xfrm>
+            <a:off x="1482451" y="1388958"/>
+            <a:ext cx="914400" cy="914400"/>
+          </a:xfrm>
+          <a:prstGeom prst="ellipse">
+            <a:avLst/>
+          </a:prstGeom>
+          <a:solidFill>
+            <a:srgbClr val="F4F3F3"/>
+          </a:solidFill>
+          <a:ln w="12700">
+            <a:noFill/>
+          </a:ln>
+        </p:spPr>
+        <p:style>
+          <a:lnRef idx="2">
+            <a:schemeClr val="accent1">
+              <a:shade val="50000"/>
+            </a:schemeClr>
+          </a:lnRef>
+          <a:fillRef idx="1">
+            <a:schemeClr val="accent1"/>
+          </a:fillRef>
+          <a:effectRef idx="0">
+            <a:schemeClr val="accent1"/>
+          </a:effectRef>
+          <a:fontRef idx="minor">
+            <a:schemeClr val="lt1"/>
+          </a:fontRef>
+        </p:style>
+        <p:txBody>
+          <a:bodyPr rot="0" spcFirstLastPara="0" vertOverflow="overflow" horzOverflow="overflow" vert="horz" wrap="square" lIns="91440" tIns="91440" rIns="91440" bIns="91440" numCol="1" spcCol="0" rtlCol="0" fromWordArt="0" anchor="ctr" anchorCtr="0" forceAA="0" compatLnSpc="1">
+            <a:prstTxWarp prst="textNoShape">
+              <a:avLst/>
+            </a:prstTxWarp>
+            <a:noAutofit/>
+          </a:bodyPr>
+          <a:lstStyle/>
+          <a:p>
+            <a:pPr algn="ctr">
+              <a:spcBef>
+                <a:spcPts val="1500"/>
+              </a:spcBef>
+              <a:spcAft>
+                <a:spcPts val="0"/>
+              </a:spcAft>
+            </a:pPr>
+            <a:r>
+              <a:rPr lang="en-US" sz="2800" b="1" dirty="0">
+                <a:solidFill>
+                  <a:srgbClr val="BE2BBB"/>
+                </a:solidFill>
+              </a:rPr>
+              <a:t>S</a:t>
+            </a:r>
+          </a:p>
+        </p:txBody>
+      </p:sp>
+      <p:sp>
+        <p:nvSpPr>
+          <p:cNvPr id="5" name="Oval 4">
+            <a:extLst>
+              <a:ext uri="{FF2B5EF4-FFF2-40B4-BE49-F238E27FC236}">
+                <a16:creationId xmlns:a16="http://schemas.microsoft.com/office/drawing/2014/main" id="{3804B353-F860-CA43-607D-6CF83F5CE96C}"/>
+              </a:ext>
+            </a:extLst>
+          </p:cNvPr>
+          <p:cNvSpPr>
+            <a:spLocks/>
+          </p:cNvSpPr>
+          <p:nvPr/>
+        </p:nvSpPr>
+        <p:spPr bwMode="gray">
+          <a:xfrm>
+            <a:off x="4255318" y="1388958"/>
+            <a:ext cx="914400" cy="914400"/>
+          </a:xfrm>
+          <a:prstGeom prst="ellipse">
+            <a:avLst/>
+          </a:prstGeom>
+          <a:solidFill>
+            <a:srgbClr val="F4F3F3"/>
+          </a:solidFill>
+          <a:ln w="12700">
+            <a:noFill/>
+          </a:ln>
+        </p:spPr>
+        <p:style>
+          <a:lnRef idx="2">
+            <a:schemeClr val="accent1">
+              <a:shade val="50000"/>
+            </a:schemeClr>
+          </a:lnRef>
+          <a:fillRef idx="1">
+            <a:schemeClr val="accent1"/>
+          </a:fillRef>
+          <a:effectRef idx="0">
+            <a:schemeClr val="accent1"/>
+          </a:effectRef>
+          <a:fontRef idx="minor">
+            <a:schemeClr val="lt1"/>
+          </a:fontRef>
+        </p:style>
+        <p:txBody>
+          <a:bodyPr rot="0" spcFirstLastPara="0" vertOverflow="overflow" horzOverflow="overflow" vert="horz" wrap="square" lIns="91440" tIns="91440" rIns="91440" bIns="91440" numCol="1" spcCol="0" rtlCol="0" fromWordArt="0" anchor="ctr" anchorCtr="0" forceAA="0" compatLnSpc="1">
+            <a:prstTxWarp prst="textNoShape">
+              <a:avLst/>
+            </a:prstTxWarp>
+            <a:noAutofit/>
+          </a:bodyPr>
+          <a:lstStyle/>
+          <a:p>
+            <a:pPr algn="ctr">
+              <a:spcBef>
+                <a:spcPts val="1500"/>
+              </a:spcBef>
+              <a:spcAft>
+                <a:spcPts val="0"/>
+              </a:spcAft>
+            </a:pPr>
+            <a:r>
+              <a:rPr lang="en-US" sz="2800" b="1" dirty="0">
+                <a:solidFill>
+                  <a:srgbClr val="BE2BBB"/>
+                </a:solidFill>
+              </a:rPr>
+              <a:t>W</a:t>
+            </a:r>
+          </a:p>
+        </p:txBody>
+      </p:sp>
+      <p:sp>
+        <p:nvSpPr>
+          <p:cNvPr id="6" name="Oval 5">
+            <a:extLst>
+              <a:ext uri="{FF2B5EF4-FFF2-40B4-BE49-F238E27FC236}">
+                <a16:creationId xmlns:a16="http://schemas.microsoft.com/office/drawing/2014/main" id="{D3D00735-C598-2703-BFAF-0F380A5392B3}"/>
+              </a:ext>
+            </a:extLst>
+          </p:cNvPr>
+          <p:cNvSpPr>
+            <a:spLocks/>
+          </p:cNvSpPr>
+          <p:nvPr/>
+        </p:nvSpPr>
+        <p:spPr bwMode="gray">
+          <a:xfrm>
+            <a:off x="7027550" y="1388958"/>
+            <a:ext cx="914400" cy="914400"/>
+          </a:xfrm>
+          <a:prstGeom prst="ellipse">
+            <a:avLst/>
+          </a:prstGeom>
+          <a:solidFill>
+            <a:srgbClr val="F4F3F3"/>
+          </a:solidFill>
+          <a:ln w="12700">
+            <a:noFill/>
+          </a:ln>
+        </p:spPr>
+        <p:style>
+          <a:lnRef idx="2">
+            <a:schemeClr val="accent1">
+              <a:shade val="50000"/>
+            </a:schemeClr>
+          </a:lnRef>
+          <a:fillRef idx="1">
+            <a:schemeClr val="accent1"/>
+          </a:fillRef>
+          <a:effectRef idx="0">
+            <a:schemeClr val="accent1"/>
+          </a:effectRef>
+          <a:fontRef idx="minor">
+            <a:schemeClr val="lt1"/>
+          </a:fontRef>
+        </p:style>
+        <p:txBody>
+          <a:bodyPr rot="0" spcFirstLastPara="0" vertOverflow="overflow" horzOverflow="overflow" vert="horz" wrap="square" lIns="91440" tIns="91440" rIns="91440" bIns="91440" numCol="1" spcCol="0" rtlCol="0" fromWordArt="0" anchor="ctr" anchorCtr="0" forceAA="0" compatLnSpc="1">
+            <a:prstTxWarp prst="textNoShape">
+              <a:avLst/>
+            </a:prstTxWarp>
+            <a:noAutofit/>
+          </a:bodyPr>
+          <a:lstStyle/>
+          <a:p>
+            <a:pPr algn="ctr">
+              <a:spcBef>
+                <a:spcPts val="1500"/>
+              </a:spcBef>
+              <a:spcAft>
+                <a:spcPts val="0"/>
+              </a:spcAft>
+            </a:pPr>
+            <a:r>
+              <a:rPr lang="en-US" sz="2800" b="1" dirty="0">
+                <a:solidFill>
+                  <a:srgbClr val="BE2BBB"/>
+                </a:solidFill>
+              </a:rPr>
+              <a:t>O</a:t>
+            </a:r>
+          </a:p>
+        </p:txBody>
+      </p:sp>
+    </p:spTree>
+    <p:extLst>
+      <p:ext uri="{BB962C8B-B14F-4D97-AF65-F5344CB8AC3E}">
+        <p14:creationId xmlns:p14="http://schemas.microsoft.com/office/powerpoint/2010/main" val="2943602238"/>
+      </p:ext>
+    </p:extLst>
+  </p:cSld>
+  <p:clrMapOvr>
+    <a:masterClrMapping/>
+  </p:clrMapOvr>
+</p:sld>
+</file>
+
+<file path=ppt/slides/slide6.xml><?xml version="1.0" encoding="utf-8"?>
+<p:sld xmlns:a="http://schemas.openxmlformats.org/drawingml/2006/main" xmlns:r="http://schemas.openxmlformats.org/officeDocument/2006/relationships" xmlns:p="http://schemas.openxmlformats.org/presentationml/2006/main">
+  <p:cSld>
+    <p:spTree>
+      <p:nvGrpSpPr>
+        <p:cNvPr id="1" name="">
+          <a:extLst>
+            <a:ext uri="{FF2B5EF4-FFF2-40B4-BE49-F238E27FC236}">
+              <a16:creationId xmlns:a16="http://schemas.microsoft.com/office/drawing/2014/main" id="{6BE0F23A-48C7-FD77-C61E-1C52E5CA8A68}"/>
+            </a:ext>
+          </a:extLst>
+        </p:cNvPr>
+        <p:cNvGrpSpPr/>
+        <p:nvPr/>
+      </p:nvGrpSpPr>
+      <p:grpSpPr>
+        <a:xfrm>
+          <a:off x="0" y="0"/>
+          <a:ext cx="0" cy="0"/>
+          <a:chOff x="0" y="0"/>
+          <a:chExt cx="0" cy="0"/>
+        </a:xfrm>
+      </p:grpSpPr>
+      <p:sp>
+        <p:nvSpPr>
+          <p:cNvPr id="2" name="Subtitle 1">
+            <a:extLst>
+              <a:ext uri="{FF2B5EF4-FFF2-40B4-BE49-F238E27FC236}">
+                <a16:creationId xmlns:a16="http://schemas.microsoft.com/office/drawing/2014/main" id="{0B0240FC-61FB-E0BB-1330-C73ED93782B7}"/>
+              </a:ext>
+            </a:extLst>
+          </p:cNvPr>
+          <p:cNvSpPr>
+            <a:spLocks noGrp="1"/>
+          </p:cNvSpPr>
+          <p:nvPr>
+            <p:ph type="subTitle" idx="1"/>
+          </p:nvPr>
+        </p:nvSpPr>
+        <p:spPr/>
+        <p:txBody>
+          <a:bodyPr/>
+          <a:lstStyle/>
+          <a:p>
+            <a:r>
+              <a:rPr lang="en-US"/>
+              <a:t>The Marketing Quotient </a:t>
+            </a:r>
+          </a:p>
+        </p:txBody>
+      </p:sp>
+      <p:sp>
+        <p:nvSpPr>
+          <p:cNvPr id="3" name="Title 2">
+            <a:extLst>
+              <a:ext uri="{FF2B5EF4-FFF2-40B4-BE49-F238E27FC236}">
+                <a16:creationId xmlns:a16="http://schemas.microsoft.com/office/drawing/2014/main" id="{CE733CBC-4E27-BDF5-1180-9621DF359DE8}"/>
+              </a:ext>
+            </a:extLst>
+          </p:cNvPr>
+          <p:cNvSpPr>
+            <a:spLocks noGrp="1"/>
+          </p:cNvSpPr>
+          <p:nvPr>
+            <p:ph type="title"/>
+          </p:nvPr>
+        </p:nvSpPr>
+        <p:spPr/>
+        <p:txBody>
+          <a:bodyPr/>
+          <a:lstStyle/>
+          <a:p>
+            <a:r>
+              <a:rPr lang="en-US" dirty="0"/>
+              <a:t>Messaging</a:t>
+            </a:r>
+            <a:br>
+              <a:rPr lang="en-US" dirty="0"/>
+            </a:br>
+            <a:r>
+              <a:rPr lang="en-US" dirty="0"/>
+              <a:t>Strategy</a:t>
+            </a:r>
+          </a:p>
+        </p:txBody>
+      </p:sp>
+      <p:sp>
+        <p:nvSpPr>
+          <p:cNvPr id="4" name="Slide Number Placeholder 3">
+            <a:extLst>
+              <a:ext uri="{FF2B5EF4-FFF2-40B4-BE49-F238E27FC236}">
+                <a16:creationId xmlns:a16="http://schemas.microsoft.com/office/drawing/2014/main" id="{F0F176EC-5284-AB88-BF21-E239FE74E5EC}"/>
+              </a:ext>
+            </a:extLst>
+          </p:cNvPr>
+          <p:cNvSpPr>
+            <a:spLocks noGrp="1"/>
+          </p:cNvSpPr>
+          <p:nvPr>
+            <p:ph type="sldNum" sz="quarter" idx="12"/>
+          </p:nvPr>
+        </p:nvSpPr>
+        <p:spPr/>
+        <p:txBody>
+          <a:bodyPr/>
+          <a:lstStyle/>
+          <a:p>
+            <a:fld id="{FC8AEAA6-477F-478D-8487-87ED88CBDFAC}" type="slidenum">
+              <a:rPr lang="en-US" smtClean="0"/>
+              <a:t>6</a:t>
+            </a:fld>
+            <a:endParaRPr lang="en-US"/>
+          </a:p>
+        </p:txBody>
+      </p:sp>
+    </p:spTree>
+    <p:extLst>
+      <p:ext uri="{BB962C8B-B14F-4D97-AF65-F5344CB8AC3E}">
+        <p14:creationId xmlns:p14="http://schemas.microsoft.com/office/powerpoint/2010/main" val="2787711679"/>
+      </p:ext>
+    </p:extLst>
+  </p:cSld>
+  <p:clrMapOvr>
+    <a:masterClrMapping/>
+  </p:clrMapOvr>
+  <mc:AlternateContent xmlns:mc="http://schemas.openxmlformats.org/markup-compatibility/2006">
+    <mc:Choice xmlns:p14="http://schemas.microsoft.com/office/powerpoint/2010/main" Requires="p14">
+      <p:transition spd="med" p14:dur="700">
+        <p:fade/>
+      </p:transition>
+    </mc:Choice>
+    <mc:Fallback>
+      <p:transition spd="med">
+        <p:fade/>
+      </p:transition>
+    </mc:Fallback>
+  </mc:AlternateContent>
+</p:sld>
+</file>
+
+<file path=ppt/slides/slide7.xml><?xml version="1.0" encoding="utf-8"?>
 <p:sld xmlns:a="http://schemas.openxmlformats.org/drawingml/2006/main" xmlns:r="http://schemas.openxmlformats.org/officeDocument/2006/relationships" xmlns:p="http://schemas.openxmlformats.org/presentationml/2006/main">
   <p:cSld>
     <p:spTree>
@@ -25421,7 +26327,7 @@
                 <a:tabLst/>
                 <a:defRPr/>
               </a:pPr>
-              <a:t>5</a:t>
+              <a:t>7</a:t>
             </a:fld>
             <a:endParaRPr kumimoji="0" lang="en-US" sz="1000" b="1" i="0" u="none" strike="noStrike" kern="1200" cap="none" spc="0" normalizeH="0" baseline="0" noProof="0">
               <a:ln>
@@ -27465,12 +28371,21 @@
 </file>
 
 <file path=customXml/item1.xml><?xml version="1.0" encoding="utf-8"?>
-<?mso-contentType ?>
-<FormTemplates xmlns="http://schemas.microsoft.com/sharepoint/v3/contenttype/forms">
-  <Display>DocumentLibraryForm</Display>
-  <Edit>DocumentLibraryForm</Edit>
-  <New>DocumentLibraryForm</New>
-</FormTemplates>
+<p:properties xmlns:p="http://schemas.microsoft.com/office/2006/metadata/properties" xmlns:xsi="http://www.w3.org/2001/XMLSchema-instance" xmlns:pc="http://schemas.microsoft.com/office/infopath/2007/PartnerControls">
+  <documentManagement>
+    <TaxCatchAll xmlns="1ff81937-46f0-48f5-a4f4-7207cfde9880" xsi:nil="true"/>
+    <SharedWithUsers xmlns="1ff81937-46f0-48f5-a4f4-7207cfde9880">
+      <UserInfo>
+        <DisplayName>Kaplan, Lori</DisplayName>
+        <AccountId>27</AccountId>
+        <AccountType/>
+      </UserInfo>
+    </SharedWithUsers>
+    <lcf76f155ced4ddcb4097134ff3c332f xmlns="d58aa00e-f3c0-46ab-a6c5-a4aa8ec7276e">
+      <Terms xmlns="http://schemas.microsoft.com/office/infopath/2007/PartnerControls"/>
+    </lcf76f155ced4ddcb4097134ff3c332f>
+  </documentManagement>
+</p:properties>
 </file>
 
 <file path=customXml/item2.xml><?xml version="1.0" encoding="utf-8"?>
@@ -27695,27 +28610,28 @@
 </file>
 
 <file path=customXml/item3.xml><?xml version="1.0" encoding="utf-8"?>
-<p:properties xmlns:p="http://schemas.microsoft.com/office/2006/metadata/properties" xmlns:xsi="http://www.w3.org/2001/XMLSchema-instance" xmlns:pc="http://schemas.microsoft.com/office/infopath/2007/PartnerControls">
-  <documentManagement>
-    <TaxCatchAll xmlns="1ff81937-46f0-48f5-a4f4-7207cfde9880" xsi:nil="true"/>
-    <SharedWithUsers xmlns="1ff81937-46f0-48f5-a4f4-7207cfde9880">
-      <UserInfo>
-        <DisplayName>Kaplan, Lori</DisplayName>
-        <AccountId>27</AccountId>
-        <AccountType/>
-      </UserInfo>
-    </SharedWithUsers>
-    <lcf76f155ced4ddcb4097134ff3c332f xmlns="d58aa00e-f3c0-46ab-a6c5-a4aa8ec7276e">
-      <Terms xmlns="http://schemas.microsoft.com/office/infopath/2007/PartnerControls"/>
-    </lcf76f155ced4ddcb4097134ff3c332f>
-  </documentManagement>
-</p:properties>
+<?mso-contentType ?>
+<FormTemplates xmlns="http://schemas.microsoft.com/sharepoint/v3/contenttype/forms">
+  <Display>DocumentLibraryForm</Display>
+  <Edit>DocumentLibraryForm</Edit>
+  <New>DocumentLibraryForm</New>
+</FormTemplates>
 </file>
 
 <file path=customXml/itemProps1.xml><?xml version="1.0" encoding="utf-8"?>
-<ds:datastoreItem xmlns:ds="http://schemas.openxmlformats.org/officeDocument/2006/customXml" ds:itemID="{A2F406D8-50A4-457E-B611-78758F79527B}">
+<ds:datastoreItem xmlns:ds="http://schemas.openxmlformats.org/officeDocument/2006/customXml" ds:itemID="{6B059CB1-CB57-45C8-B58C-EB9957E73A5D}">
   <ds:schemaRefs>
-    <ds:schemaRef ds:uri="http://schemas.microsoft.com/sharepoint/v3/contenttype/forms"/>
+    <ds:schemaRef ds:uri="1ff81937-46f0-48f5-a4f4-7207cfde9880"/>
+    <ds:schemaRef ds:uri="4ce1936b-43e3-436c-964a-a212a0edf4f1"/>
+    <ds:schemaRef ds:uri="d58aa00e-f3c0-46ab-a6c5-a4aa8ec7276e"/>
+    <ds:schemaRef ds:uri="http://purl.org/dc/dcmitype/"/>
+    <ds:schemaRef ds:uri="http://purl.org/dc/elements/1.1/"/>
+    <ds:schemaRef ds:uri="http://purl.org/dc/terms/"/>
+    <ds:schemaRef ds:uri="http://schemas.microsoft.com/office/2006/documentManagement/types"/>
+    <ds:schemaRef ds:uri="http://schemas.microsoft.com/office/2006/metadata/properties"/>
+    <ds:schemaRef ds:uri="http://schemas.microsoft.com/office/infopath/2007/PartnerControls"/>
+    <ds:schemaRef ds:uri="http://schemas.openxmlformats.org/package/2006/metadata/core-properties"/>
+    <ds:schemaRef ds:uri="http://www.w3.org/XML/1998/namespace"/>
   </ds:schemaRefs>
 </ds:datastoreItem>
 </file>
@@ -27740,19 +28656,9 @@
 </file>
 
 <file path=customXml/itemProps3.xml><?xml version="1.0" encoding="utf-8"?>
-<ds:datastoreItem xmlns:ds="http://schemas.openxmlformats.org/officeDocument/2006/customXml" ds:itemID="{6B059CB1-CB57-45C8-B58C-EB9957E73A5D}">
+<ds:datastoreItem xmlns:ds="http://schemas.openxmlformats.org/officeDocument/2006/customXml" ds:itemID="{A2F406D8-50A4-457E-B611-78758F79527B}">
   <ds:schemaRefs>
-    <ds:schemaRef ds:uri="1ff81937-46f0-48f5-a4f4-7207cfde9880"/>
-    <ds:schemaRef ds:uri="4ce1936b-43e3-436c-964a-a212a0edf4f1"/>
-    <ds:schemaRef ds:uri="d58aa00e-f3c0-46ab-a6c5-a4aa8ec7276e"/>
-    <ds:schemaRef ds:uri="http://purl.org/dc/dcmitype/"/>
-    <ds:schemaRef ds:uri="http://purl.org/dc/elements/1.1/"/>
-    <ds:schemaRef ds:uri="http://purl.org/dc/terms/"/>
-    <ds:schemaRef ds:uri="http://schemas.microsoft.com/office/2006/documentManagement/types"/>
-    <ds:schemaRef ds:uri="http://schemas.microsoft.com/office/2006/metadata/properties"/>
-    <ds:schemaRef ds:uri="http://schemas.microsoft.com/office/infopath/2007/PartnerControls"/>
-    <ds:schemaRef ds:uri="http://schemas.openxmlformats.org/package/2006/metadata/core-properties"/>
-    <ds:schemaRef ds:uri="http://www.w3.org/XML/1998/namespace"/>
+    <ds:schemaRef ds:uri="http://schemas.microsoft.com/sharepoint/v3/contenttype/forms"/>
   </ds:schemaRefs>
 </ds:datastoreItem>
 </file>

</xml_diff>

<commit_message>
temp for new swot template
</commit_message>
<xml_diff>
--- a/example_files/example slides.pptx
+++ b/example_files/example slides.pptx
@@ -12,7 +12,7 @@
     <p:sldId id="272" r:id="rId6"/>
     <p:sldId id="2147483474" r:id="rId7"/>
     <p:sldId id="2147483487" r:id="rId8"/>
-    <p:sldId id="2032093144" r:id="rId9"/>
+    <p:sldId id="2032093143" r:id="rId9"/>
     <p:sldId id="2147483542" r:id="rId10"/>
     <p:sldId id="2147483541" r:id="rId11"/>
   </p:sldIdLst>
@@ -209,7 +209,7 @@
           <a:p>
             <a:fld id="{41114AA6-83B2-48B3-ADA3-54A34F936A3E}" type="datetimeFigureOut">
               <a:rPr lang="en-US" smtClean="0"/>
-              <a:t>3/11/2026</a:t>
+              <a:t>3/17/2026</a:t>
             </a:fld>
             <a:endParaRPr lang="en-US"/>
           </a:p>
@@ -25295,13 +25295,7 @@
   <p:cSld>
     <p:spTree>
       <p:nvGrpSpPr>
-        <p:cNvPr id="1" name="">
-          <a:extLst>
-            <a:ext uri="{FF2B5EF4-FFF2-40B4-BE49-F238E27FC236}">
-              <a16:creationId xmlns:a16="http://schemas.microsoft.com/office/drawing/2014/main" id="{5CA6A10E-3EC0-FD24-3FEF-80972A962D3D}"/>
-            </a:ext>
-          </a:extLst>
-        </p:cNvPr>
+        <p:cNvPr id="1" name=""/>
         <p:cNvGrpSpPr/>
         <p:nvPr/>
       </p:nvGrpSpPr>
@@ -25315,13 +25309,253 @@
       </p:grpSpPr>
       <p:sp>
         <p:nvSpPr>
-          <p:cNvPr id="2" name="Title 1">
-            <a:extLst>
-              <a:ext uri="{FF2B5EF4-FFF2-40B4-BE49-F238E27FC236}">
-                <a16:creationId xmlns:a16="http://schemas.microsoft.com/office/drawing/2014/main" id="{9DADC100-07D5-00E4-8DB3-CB6E44AAC2ED}"/>
-              </a:ext>
-            </a:extLst>
-          </p:cNvPr>
+          <p:cNvPr id="32" name="Rectangle 31"/>
+          <p:cNvSpPr/>
+          <p:nvPr/>
+        </p:nvSpPr>
+        <p:spPr bwMode="gray">
+          <a:xfrm>
+            <a:off x="8867553" y="1203325"/>
+            <a:ext cx="2772759" cy="4451350"/>
+          </a:xfrm>
+          <a:prstGeom prst="rect">
+            <a:avLst/>
+          </a:prstGeom>
+          <a:solidFill>
+            <a:schemeClr val="tx1"/>
+          </a:solidFill>
+          <a:ln w="9525">
+            <a:noFill/>
+          </a:ln>
+        </p:spPr>
+        <p:style>
+          <a:lnRef idx="2">
+            <a:schemeClr val="accent1">
+              <a:shade val="50000"/>
+            </a:schemeClr>
+          </a:lnRef>
+          <a:fillRef idx="1">
+            <a:schemeClr val="accent1"/>
+          </a:fillRef>
+          <a:effectRef idx="0">
+            <a:schemeClr val="accent1"/>
+          </a:effectRef>
+          <a:fontRef idx="minor">
+            <a:schemeClr val="lt1"/>
+          </a:fontRef>
+        </p:style>
+        <p:txBody>
+          <a:bodyPr rot="0" spcFirstLastPara="0" vertOverflow="overflow" horzOverflow="overflow" vert="horz" wrap="square" lIns="91440" tIns="1371600" rIns="91440" bIns="91440" numCol="1" spcCol="0" rtlCol="0" fromWordArt="0" anchor="t" anchorCtr="0" forceAA="0" compatLnSpc="1">
+            <a:prstTxWarp prst="textNoShape">
+              <a:avLst/>
+            </a:prstTxWarp>
+            <a:noAutofit/>
+          </a:bodyPr>
+          <a:lstStyle/>
+          <a:p>
+            <a:pPr algn="ctr">
+              <a:spcBef>
+                <a:spcPts val="1500"/>
+              </a:spcBef>
+              <a:spcAft>
+                <a:spcPts val="0"/>
+              </a:spcAft>
+            </a:pPr>
+            <a:r>
+              <a:rPr lang="en-US" sz="2000" b="1" dirty="0">
+                <a:solidFill>
+                  <a:schemeClr val="bg1"/>
+                </a:solidFill>
+              </a:rPr>
+              <a:t>Threats</a:t>
+            </a:r>
+          </a:p>
+          <a:p>
+            <a:pPr>
+              <a:spcBef>
+                <a:spcPts val="1500"/>
+              </a:spcBef>
+            </a:pPr>
+            <a:r>
+              <a:rPr lang="en-US" sz="1500" dirty="0">
+                <a:solidFill>
+                  <a:schemeClr val="bg1"/>
+                </a:solidFill>
+                <a:cs typeface="Arial" panose="020B0604020202020204" pitchFamily="34" charset="0"/>
+              </a:rPr>
+              <a:t>Placeholder-threats</a:t>
+            </a:r>
+          </a:p>
+        </p:txBody>
+      </p:sp>
+      <p:sp>
+        <p:nvSpPr>
+          <p:cNvPr id="30" name="Rectangle 29"/>
+          <p:cNvSpPr/>
+          <p:nvPr/>
+        </p:nvSpPr>
+        <p:spPr bwMode="gray">
+          <a:xfrm>
+            <a:off x="3321506" y="1203325"/>
+            <a:ext cx="2772759" cy="4451350"/>
+          </a:xfrm>
+          <a:prstGeom prst="rect">
+            <a:avLst/>
+          </a:prstGeom>
+          <a:solidFill>
+            <a:schemeClr val="tx1">
+              <a:lumMod val="20000"/>
+              <a:lumOff val="80000"/>
+            </a:schemeClr>
+          </a:solidFill>
+          <a:ln w="9525">
+            <a:noFill/>
+          </a:ln>
+        </p:spPr>
+        <p:style>
+          <a:lnRef idx="2">
+            <a:schemeClr val="accent1">
+              <a:shade val="50000"/>
+            </a:schemeClr>
+          </a:lnRef>
+          <a:fillRef idx="1">
+            <a:schemeClr val="accent1"/>
+          </a:fillRef>
+          <a:effectRef idx="0">
+            <a:schemeClr val="accent1"/>
+          </a:effectRef>
+          <a:fontRef idx="minor">
+            <a:schemeClr val="lt1"/>
+          </a:fontRef>
+        </p:style>
+        <p:txBody>
+          <a:bodyPr rot="0" spcFirstLastPara="0" vertOverflow="overflow" horzOverflow="overflow" vert="horz" wrap="square" lIns="91440" tIns="1371600" rIns="91440" bIns="91440" numCol="1" spcCol="0" rtlCol="0" fromWordArt="0" anchor="t" anchorCtr="0" forceAA="0" compatLnSpc="1">
+            <a:prstTxWarp prst="textNoShape">
+              <a:avLst/>
+            </a:prstTxWarp>
+            <a:noAutofit/>
+          </a:bodyPr>
+          <a:lstStyle/>
+          <a:p>
+            <a:pPr algn="ctr">
+              <a:spcBef>
+                <a:spcPts val="1500"/>
+              </a:spcBef>
+              <a:spcAft>
+                <a:spcPts val="0"/>
+              </a:spcAft>
+            </a:pPr>
+            <a:r>
+              <a:rPr lang="en-US" sz="2000" b="1" dirty="0">
+                <a:solidFill>
+                  <a:schemeClr val="bg1"/>
+                </a:solidFill>
+              </a:rPr>
+              <a:t>Weaknesses</a:t>
+            </a:r>
+          </a:p>
+          <a:p>
+            <a:pPr>
+              <a:spcBef>
+                <a:spcPts val="1500"/>
+              </a:spcBef>
+            </a:pPr>
+            <a:r>
+              <a:rPr lang="en-US" sz="1500" dirty="0">
+                <a:solidFill>
+                  <a:schemeClr val="bg1"/>
+                </a:solidFill>
+                <a:cs typeface="Arial" panose="020B0604020202020204" pitchFamily="34" charset="0"/>
+              </a:rPr>
+              <a:t>Placeholder-weaknesses</a:t>
+            </a:r>
+          </a:p>
+        </p:txBody>
+      </p:sp>
+      <p:sp>
+        <p:nvSpPr>
+          <p:cNvPr id="31" name="Rectangle 30"/>
+          <p:cNvSpPr/>
+          <p:nvPr/>
+        </p:nvSpPr>
+        <p:spPr bwMode="gray">
+          <a:xfrm>
+            <a:off x="6093738" y="1203325"/>
+            <a:ext cx="2772759" cy="4451350"/>
+          </a:xfrm>
+          <a:prstGeom prst="rect">
+            <a:avLst/>
+          </a:prstGeom>
+          <a:solidFill>
+            <a:srgbClr val="0070C0"/>
+          </a:solidFill>
+          <a:ln w="9525">
+            <a:noFill/>
+          </a:ln>
+        </p:spPr>
+        <p:style>
+          <a:lnRef idx="2">
+            <a:schemeClr val="accent1">
+              <a:shade val="50000"/>
+            </a:schemeClr>
+          </a:lnRef>
+          <a:fillRef idx="1">
+            <a:schemeClr val="accent1"/>
+          </a:fillRef>
+          <a:effectRef idx="0">
+            <a:schemeClr val="accent1"/>
+          </a:effectRef>
+          <a:fontRef idx="minor">
+            <a:schemeClr val="lt1"/>
+          </a:fontRef>
+        </p:style>
+        <p:txBody>
+          <a:bodyPr rot="0" spcFirstLastPara="0" vertOverflow="overflow" horzOverflow="overflow" vert="horz" wrap="square" lIns="91440" tIns="1371600" rIns="91440" bIns="91440" numCol="1" spcCol="0" rtlCol="0" fromWordArt="0" anchor="t" anchorCtr="0" forceAA="0" compatLnSpc="1">
+            <a:prstTxWarp prst="textNoShape">
+              <a:avLst/>
+            </a:prstTxWarp>
+            <a:noAutofit/>
+          </a:bodyPr>
+          <a:lstStyle/>
+          <a:p>
+            <a:pPr algn="ctr">
+              <a:spcBef>
+                <a:spcPts val="1500"/>
+              </a:spcBef>
+              <a:spcAft>
+                <a:spcPts val="0"/>
+              </a:spcAft>
+            </a:pPr>
+            <a:r>
+              <a:rPr lang="en-US" sz="2000" b="1" dirty="0">
+                <a:solidFill>
+                  <a:schemeClr val="bg1"/>
+                </a:solidFill>
+              </a:rPr>
+              <a:t>Opportunities</a:t>
+            </a:r>
+          </a:p>
+          <a:p>
+            <a:pPr>
+              <a:spcBef>
+                <a:spcPts val="1500"/>
+              </a:spcBef>
+            </a:pPr>
+            <a:r>
+              <a:rPr lang="en-US" sz="1500" dirty="0">
+                <a:solidFill>
+                  <a:schemeClr val="bg1"/>
+                </a:solidFill>
+                <a:cs typeface="Arial" panose="020B0604020202020204" pitchFamily="34" charset="0"/>
+              </a:rPr>
+              <a:t>Placeholder-opportunities</a:t>
+            </a:r>
+          </a:p>
+        </p:txBody>
+      </p:sp>
+      <p:sp>
+        <p:nvSpPr>
+          <p:cNvPr id="2" name="Title 1"/>
           <p:cNvSpPr>
             <a:spLocks noGrp="1"/>
           </p:cNvSpPr>
@@ -25329,12 +25563,7 @@
             <p:ph type="title"/>
           </p:nvPr>
         </p:nvSpPr>
-        <p:spPr bwMode="gray">
-          <a:xfrm>
-            <a:off x="548640" y="429768"/>
-            <a:ext cx="11091672" cy="984885"/>
-          </a:xfrm>
-        </p:spPr>
+        <p:spPr bwMode="gray"/>
         <p:txBody>
           <a:bodyPr/>
           <a:lstStyle/>
@@ -25346,422 +25575,113 @@
           </a:p>
         </p:txBody>
       </p:sp>
-      <p:graphicFrame>
-        <p:nvGraphicFramePr>
-          <p:cNvPr id="8" name="Table 7">
+      <p:sp>
+        <p:nvSpPr>
+          <p:cNvPr id="4" name="Rectangle 3"/>
+          <p:cNvSpPr/>
+          <p:nvPr/>
+        </p:nvSpPr>
+        <p:spPr bwMode="gray">
+          <a:xfrm>
+            <a:off x="547164" y="1203325"/>
+            <a:ext cx="2772759" cy="4451350"/>
+          </a:xfrm>
+          <a:prstGeom prst="rect">
+            <a:avLst/>
+          </a:prstGeom>
+          <a:solidFill>
+            <a:srgbClr val="BE2BBB"/>
+          </a:solidFill>
+          <a:ln w="9525">
+            <a:noFill/>
+          </a:ln>
+        </p:spPr>
+        <p:style>
+          <a:lnRef idx="2">
+            <a:schemeClr val="accent1">
+              <a:shade val="50000"/>
+            </a:schemeClr>
+          </a:lnRef>
+          <a:fillRef idx="1">
+            <a:schemeClr val="accent1"/>
+          </a:fillRef>
+          <a:effectRef idx="0">
+            <a:schemeClr val="accent1"/>
+          </a:effectRef>
+          <a:fontRef idx="minor">
+            <a:schemeClr val="lt1"/>
+          </a:fontRef>
+        </p:style>
+        <p:txBody>
+          <a:bodyPr rot="0" spcFirstLastPara="0" vertOverflow="overflow" horzOverflow="overflow" vert="horz" wrap="square" lIns="91440" tIns="1371600" rIns="91440" bIns="91440" numCol="1" spcCol="0" rtlCol="0" fromWordArt="0" anchor="t" anchorCtr="0" forceAA="0" compatLnSpc="1">
+            <a:prstTxWarp prst="textNoShape">
+              <a:avLst/>
+            </a:prstTxWarp>
+            <a:noAutofit/>
+          </a:bodyPr>
+          <a:lstStyle/>
+          <a:p>
+            <a:pPr algn="ctr">
+              <a:spcBef>
+                <a:spcPts val="1500"/>
+              </a:spcBef>
+              <a:spcAft>
+                <a:spcPts val="0"/>
+              </a:spcAft>
+            </a:pPr>
+            <a:r>
+              <a:rPr lang="en-US" sz="2000" b="1" dirty="0">
+                <a:solidFill>
+                  <a:schemeClr val="bg1"/>
+                </a:solidFill>
+              </a:rPr>
+              <a:t>Strengths</a:t>
+            </a:r>
+          </a:p>
+          <a:p>
+            <a:pPr>
+              <a:spcBef>
+                <a:spcPts val="1500"/>
+              </a:spcBef>
+              <a:spcAft>
+                <a:spcPts val="0"/>
+              </a:spcAft>
+            </a:pPr>
+            <a:r>
+              <a:rPr lang="en-US" sz="1500" dirty="0">
+                <a:solidFill>
+                  <a:schemeClr val="bg1"/>
+                </a:solidFill>
+                <a:cs typeface="Arial" panose="020B0604020202020204" pitchFamily="34" charset="0"/>
+              </a:rPr>
+              <a:t>Placeholder-strengths</a:t>
+            </a:r>
+          </a:p>
+          <a:p>
+            <a:pPr marL="285750" indent="-285750">
+              <a:spcBef>
+                <a:spcPts val="1500"/>
+              </a:spcBef>
+              <a:spcAft>
+                <a:spcPts val="0"/>
+              </a:spcAft>
+              <a:buFont typeface="Arial" panose="020B0604020202020204" pitchFamily="34" charset="0"/>
+              <a:buChar char="•"/>
+            </a:pPr>
+            <a:endParaRPr lang="en-US" sz="1400" dirty="0">
+              <a:solidFill>
+                <a:schemeClr val="bg1"/>
+              </a:solidFill>
+            </a:endParaRPr>
+          </a:p>
+        </p:txBody>
+      </p:sp>
+      <p:sp>
+        <p:nvSpPr>
+          <p:cNvPr id="11" name="Oval 10">
             <a:extLst>
               <a:ext uri="{FF2B5EF4-FFF2-40B4-BE49-F238E27FC236}">
-                <a16:creationId xmlns:a16="http://schemas.microsoft.com/office/drawing/2014/main" id="{5CF0DAC7-5061-A54D-9BBB-AAC06B0055EC}"/>
-              </a:ext>
-            </a:extLst>
-          </p:cNvPr>
-          <p:cNvGraphicFramePr>
-            <a:graphicFrameLocks noGrp="1"/>
-          </p:cNvGraphicFramePr>
-          <p:nvPr/>
-        </p:nvGraphicFramePr>
-        <p:xfrm>
-          <a:off x="548639" y="1907118"/>
-          <a:ext cx="11091672" cy="4389120"/>
-        </p:xfrm>
-        <a:graphic>
-          <a:graphicData uri="http://schemas.openxmlformats.org/drawingml/2006/table">
-            <a:tbl>
-              <a:tblPr firstRow="1" bandRow="1">
-                <a:tableStyleId>{5C22544A-7EE6-4342-B048-85BDC9FD1C3A}</a:tableStyleId>
-              </a:tblPr>
-              <a:tblGrid>
-                <a:gridCol w="2772918">
-                  <a:extLst>
-                    <a:ext uri="{9D8B030D-6E8A-4147-A177-3AD203B41FA5}">
-                      <a16:colId xmlns:a16="http://schemas.microsoft.com/office/drawing/2014/main" val="1322876460"/>
-                    </a:ext>
-                  </a:extLst>
-                </a:gridCol>
-                <a:gridCol w="2772918">
-                  <a:extLst>
-                    <a:ext uri="{9D8B030D-6E8A-4147-A177-3AD203B41FA5}">
-                      <a16:colId xmlns:a16="http://schemas.microsoft.com/office/drawing/2014/main" val="2009499124"/>
-                    </a:ext>
-                  </a:extLst>
-                </a:gridCol>
-                <a:gridCol w="2772918">
-                  <a:extLst>
-                    <a:ext uri="{9D8B030D-6E8A-4147-A177-3AD203B41FA5}">
-                      <a16:colId xmlns:a16="http://schemas.microsoft.com/office/drawing/2014/main" val="490926120"/>
-                    </a:ext>
-                  </a:extLst>
-                </a:gridCol>
-                <a:gridCol w="2772918">
-                  <a:extLst>
-                    <a:ext uri="{9D8B030D-6E8A-4147-A177-3AD203B41FA5}">
-                      <a16:colId xmlns:a16="http://schemas.microsoft.com/office/drawing/2014/main" val="324268400"/>
-                    </a:ext>
-                  </a:extLst>
-                </a:gridCol>
-              </a:tblGrid>
-              <a:tr h="914400">
-                <a:tc>
-                  <a:txBody>
-                    <a:bodyPr/>
-                    <a:lstStyle/>
-                    <a:p>
-                      <a:pPr marL="0" marR="0" lvl="0" indent="0" algn="ctr" defTabSz="914400" rtl="0" eaLnBrk="1" fontAlgn="auto" latinLnBrk="0" hangingPunct="1">
-                        <a:lnSpc>
-                          <a:spcPct val="100000"/>
-                        </a:lnSpc>
-                        <a:spcBef>
-                          <a:spcPts val="0"/>
-                        </a:spcBef>
-                        <a:spcAft>
-                          <a:spcPts val="0"/>
-                        </a:spcAft>
-                        <a:buClrTx/>
-                        <a:buSzTx/>
-                        <a:buFontTx/>
-                        <a:buNone/>
-                        <a:tabLst/>
-                        <a:defRPr/>
-                      </a:pPr>
-                      <a:r>
-                        <a:rPr lang="en-US" sz="2000" b="1" dirty="0">
-                          <a:solidFill>
-                            <a:schemeClr val="tx1"/>
-                          </a:solidFill>
-                        </a:rPr>
-                        <a:t>Strengths</a:t>
-                      </a:r>
-                    </a:p>
-                  </a:txBody>
-                  <a:tcPr marB="91440" anchor="b">
-                    <a:lnL w="12700" cmpd="sng">
-                      <a:noFill/>
-                    </a:lnL>
-                    <a:lnR w="12700" cmpd="sng">
-                      <a:noFill/>
-                    </a:lnR>
-                    <a:lnT w="12700" cmpd="sng">
-                      <a:noFill/>
-                    </a:lnT>
-                    <a:lnB w="38100" cmpd="sng">
-                      <a:noFill/>
-                    </a:lnB>
-                    <a:lnTlToBr w="12700" cmpd="sng">
-                      <a:noFill/>
-                      <a:prstDash val="solid"/>
-                    </a:lnTlToBr>
-                    <a:lnBlToTr w="12700" cmpd="sng">
-                      <a:noFill/>
-                      <a:prstDash val="solid"/>
-                    </a:lnBlToTr>
-                    <a:solidFill>
-                      <a:schemeClr val="accent2">
-                        <a:lumMod val="20000"/>
-                        <a:lumOff val="80000"/>
-                      </a:schemeClr>
-                    </a:solidFill>
-                  </a:tcPr>
-                </a:tc>
-                <a:tc>
-                  <a:txBody>
-                    <a:bodyPr/>
-                    <a:lstStyle/>
-                    <a:p>
-                      <a:pPr marL="0" marR="0" lvl="0" indent="0" algn="ctr" defTabSz="914400" rtl="0" eaLnBrk="1" fontAlgn="auto" latinLnBrk="0" hangingPunct="1">
-                        <a:lnSpc>
-                          <a:spcPct val="100000"/>
-                        </a:lnSpc>
-                        <a:spcBef>
-                          <a:spcPts val="0"/>
-                        </a:spcBef>
-                        <a:spcAft>
-                          <a:spcPts val="0"/>
-                        </a:spcAft>
-                        <a:buClrTx/>
-                        <a:buSzTx/>
-                        <a:buFontTx/>
-                        <a:buNone/>
-                        <a:tabLst/>
-                        <a:defRPr/>
-                      </a:pPr>
-                      <a:r>
-                        <a:rPr lang="en-US" sz="2000" b="1" dirty="0">
-                          <a:solidFill>
-                            <a:schemeClr val="tx1"/>
-                          </a:solidFill>
-                        </a:rPr>
-                        <a:t>Weaknesses</a:t>
-                      </a:r>
-                    </a:p>
-                  </a:txBody>
-                  <a:tcPr marB="91440" anchor="b">
-                    <a:lnL w="12700" cmpd="sng">
-                      <a:noFill/>
-                    </a:lnL>
-                    <a:lnR w="12700" cmpd="sng">
-                      <a:noFill/>
-                    </a:lnR>
-                    <a:lnT w="12700" cmpd="sng">
-                      <a:noFill/>
-                    </a:lnT>
-                    <a:lnB w="38100" cmpd="sng">
-                      <a:noFill/>
-                    </a:lnB>
-                    <a:lnTlToBr w="12700" cmpd="sng">
-                      <a:noFill/>
-                      <a:prstDash val="solid"/>
-                    </a:lnTlToBr>
-                    <a:lnBlToTr w="12700" cmpd="sng">
-                      <a:noFill/>
-                      <a:prstDash val="solid"/>
-                    </a:lnBlToTr>
-                    <a:solidFill>
-                      <a:srgbClr val="EEE7E7"/>
-                    </a:solidFill>
-                  </a:tcPr>
-                </a:tc>
-                <a:tc>
-                  <a:txBody>
-                    <a:bodyPr/>
-                    <a:lstStyle/>
-                    <a:p>
-                      <a:pPr marL="0" marR="0" lvl="0" indent="0" algn="ctr" defTabSz="914400" rtl="0" eaLnBrk="1" fontAlgn="auto" latinLnBrk="0" hangingPunct="1">
-                        <a:lnSpc>
-                          <a:spcPct val="100000"/>
-                        </a:lnSpc>
-                        <a:spcBef>
-                          <a:spcPts val="0"/>
-                        </a:spcBef>
-                        <a:spcAft>
-                          <a:spcPts val="0"/>
-                        </a:spcAft>
-                        <a:buClrTx/>
-                        <a:buSzTx/>
-                        <a:buFontTx/>
-                        <a:buNone/>
-                        <a:tabLst/>
-                        <a:defRPr/>
-                      </a:pPr>
-                      <a:r>
-                        <a:rPr lang="en-US" sz="2000" b="1" kern="1200" dirty="0">
-                          <a:solidFill>
-                            <a:schemeClr val="tx1"/>
-                          </a:solidFill>
-                          <a:latin typeface="+mn-lt"/>
-                          <a:ea typeface="+mn-ea"/>
-                          <a:cs typeface="+mn-cs"/>
-                        </a:rPr>
-                        <a:t>Opportunities</a:t>
-                      </a:r>
-                    </a:p>
-                  </a:txBody>
-                  <a:tcPr marB="91440" anchor="b">
-                    <a:lnL w="12700" cmpd="sng">
-                      <a:noFill/>
-                    </a:lnL>
-                    <a:lnR w="12700" cmpd="sng">
-                      <a:noFill/>
-                    </a:lnR>
-                    <a:lnT w="12700" cmpd="sng">
-                      <a:noFill/>
-                    </a:lnT>
-                    <a:lnB w="38100" cmpd="sng">
-                      <a:noFill/>
-                    </a:lnB>
-                    <a:lnTlToBr w="12700" cmpd="sng">
-                      <a:noFill/>
-                      <a:prstDash val="solid"/>
-                    </a:lnTlToBr>
-                    <a:lnBlToTr w="12700" cmpd="sng">
-                      <a:noFill/>
-                      <a:prstDash val="solid"/>
-                    </a:lnBlToTr>
-                    <a:solidFill>
-                      <a:schemeClr val="accent2">
-                        <a:lumMod val="20000"/>
-                        <a:lumOff val="80000"/>
-                      </a:schemeClr>
-                    </a:solidFill>
-                  </a:tcPr>
-                </a:tc>
-                <a:tc>
-                  <a:txBody>
-                    <a:bodyPr/>
-                    <a:lstStyle/>
-                    <a:p>
-                      <a:pPr marL="0" marR="0" lvl="0" indent="0" algn="ctr" defTabSz="914400" rtl="0" eaLnBrk="1" fontAlgn="auto" latinLnBrk="0" hangingPunct="1">
-                        <a:lnSpc>
-                          <a:spcPct val="100000"/>
-                        </a:lnSpc>
-                        <a:spcBef>
-                          <a:spcPts val="0"/>
-                        </a:spcBef>
-                        <a:spcAft>
-                          <a:spcPts val="0"/>
-                        </a:spcAft>
-                        <a:buClrTx/>
-                        <a:buSzTx/>
-                        <a:buFontTx/>
-                        <a:buNone/>
-                        <a:tabLst/>
-                        <a:defRPr/>
-                      </a:pPr>
-                      <a:r>
-                        <a:rPr lang="en-US" sz="2000" b="1" kern="1200" dirty="0">
-                          <a:solidFill>
-                            <a:schemeClr val="tx1"/>
-                          </a:solidFill>
-                          <a:latin typeface="+mn-lt"/>
-                          <a:ea typeface="+mn-ea"/>
-                          <a:cs typeface="+mn-cs"/>
-                        </a:rPr>
-                        <a:t>Threats</a:t>
-                      </a:r>
-                    </a:p>
-                  </a:txBody>
-                  <a:tcPr marB="91440" anchor="b">
-                    <a:lnL w="12700" cmpd="sng">
-                      <a:noFill/>
-                    </a:lnL>
-                    <a:lnR w="12700" cmpd="sng">
-                      <a:noFill/>
-                    </a:lnR>
-                    <a:lnT w="12700" cmpd="sng">
-                      <a:noFill/>
-                    </a:lnT>
-                    <a:lnB w="38100" cmpd="sng">
-                      <a:noFill/>
-                    </a:lnB>
-                    <a:lnTlToBr w="12700" cmpd="sng">
-                      <a:noFill/>
-                      <a:prstDash val="solid"/>
-                    </a:lnTlToBr>
-                    <a:lnBlToTr w="12700" cmpd="sng">
-                      <a:noFill/>
-                      <a:prstDash val="solid"/>
-                    </a:lnBlToTr>
-                    <a:solidFill>
-                      <a:srgbClr val="EEE7E7"/>
-                    </a:solidFill>
-                  </a:tcPr>
-                </a:tc>
-                <a:extLst>
-                  <a:ext uri="{0D108BD9-81ED-4DB2-BD59-A6C34878D82A}">
-                    <a16:rowId xmlns:a16="http://schemas.microsoft.com/office/drawing/2014/main" val="124223165"/>
-                  </a:ext>
-                </a:extLst>
-              </a:tr>
-              <a:tr h="3474720">
-                <a:tc>
-                  <a:txBody>
-                    <a:bodyPr/>
-                    <a:lstStyle/>
-                    <a:p>
-                      <a:pPr algn="ctr"/>
-                      <a:endParaRPr lang="en-US" sz="1400" dirty="0">
-                        <a:solidFill>
-                          <a:schemeClr val="tx1"/>
-                        </a:solidFill>
-                      </a:endParaRPr>
-                    </a:p>
-                  </a:txBody>
-                  <a:tcPr anchor="ctr">
-                    <a:lnT w="38100" cmpd="sng">
-                      <a:noFill/>
-                    </a:lnT>
-                    <a:solidFill>
-                      <a:schemeClr val="accent2">
-                        <a:lumMod val="20000"/>
-                        <a:lumOff val="80000"/>
-                      </a:schemeClr>
-                    </a:solidFill>
-                  </a:tcPr>
-                </a:tc>
-                <a:tc>
-                  <a:txBody>
-                    <a:bodyPr/>
-                    <a:lstStyle/>
-                    <a:p>
-                      <a:pPr algn="ctr"/>
-                      <a:endParaRPr lang="en-US" sz="1400" dirty="0">
-                        <a:solidFill>
-                          <a:schemeClr val="tx1"/>
-                        </a:solidFill>
-                      </a:endParaRPr>
-                    </a:p>
-                  </a:txBody>
-                  <a:tcPr anchor="ctr">
-                    <a:lnT w="38100" cmpd="sng">
-                      <a:noFill/>
-                    </a:lnT>
-                    <a:solidFill>
-                      <a:srgbClr val="EEE7E7"/>
-                    </a:solidFill>
-                  </a:tcPr>
-                </a:tc>
-                <a:tc>
-                  <a:txBody>
-                    <a:bodyPr/>
-                    <a:lstStyle/>
-                    <a:p>
-                      <a:pPr algn="ctr"/>
-                      <a:endParaRPr lang="en-US" sz="1400" dirty="0">
-                        <a:solidFill>
-                          <a:schemeClr val="tx1"/>
-                        </a:solidFill>
-                      </a:endParaRPr>
-                    </a:p>
-                  </a:txBody>
-                  <a:tcPr anchor="ctr">
-                    <a:lnT w="38100" cmpd="sng">
-                      <a:noFill/>
-                    </a:lnT>
-                    <a:solidFill>
-                      <a:schemeClr val="accent2">
-                        <a:lumMod val="20000"/>
-                        <a:lumOff val="80000"/>
-                      </a:schemeClr>
-                    </a:solidFill>
-                  </a:tcPr>
-                </a:tc>
-                <a:tc>
-                  <a:txBody>
-                    <a:bodyPr/>
-                    <a:lstStyle/>
-                    <a:p>
-                      <a:pPr algn="ctr"/>
-                      <a:endParaRPr lang="en-US" sz="1400" dirty="0">
-                        <a:solidFill>
-                          <a:schemeClr val="tx1"/>
-                        </a:solidFill>
-                      </a:endParaRPr>
-                    </a:p>
-                  </a:txBody>
-                  <a:tcPr anchor="ctr">
-                    <a:lnT w="38100" cmpd="sng">
-                      <a:noFill/>
-                    </a:lnT>
-                    <a:solidFill>
-                      <a:srgbClr val="EEE7E7"/>
-                    </a:solidFill>
-                  </a:tcPr>
-                </a:tc>
-                <a:extLst>
-                  <a:ext uri="{0D108BD9-81ED-4DB2-BD59-A6C34878D82A}">
-                    <a16:rowId xmlns:a16="http://schemas.microsoft.com/office/drawing/2014/main" val="2274849163"/>
-                  </a:ext>
-                </a:extLst>
-              </a:tr>
-            </a:tbl>
-          </a:graphicData>
-        </a:graphic>
-      </p:graphicFrame>
-      <p:sp>
-        <p:nvSpPr>
-          <p:cNvPr id="20" name="Oval 19">
-            <a:extLst>
-              <a:ext uri="{FF2B5EF4-FFF2-40B4-BE49-F238E27FC236}">
-                <a16:creationId xmlns:a16="http://schemas.microsoft.com/office/drawing/2014/main" id="{ED62D64A-5E66-A2A8-298B-8F3014CD8CE9}"/>
+                <a16:creationId xmlns:a16="http://schemas.microsoft.com/office/drawing/2014/main" id="{5A1BB8C1-CA06-45D5-B9EE-1B5166BFC63E}"/>
               </a:ext>
             </a:extLst>
           </p:cNvPr>
@@ -25772,7 +25692,7 @@
         </p:nvSpPr>
         <p:spPr bwMode="gray">
           <a:xfrm>
-            <a:off x="9795149" y="1388958"/>
+            <a:off x="1477819" y="1464375"/>
             <a:ext cx="914400" cy="914400"/>
           </a:xfrm>
           <a:prstGeom prst="ellipse">
@@ -25824,17 +25744,17 @@
                   <a:srgbClr val="BE2BBB"/>
                 </a:solidFill>
               </a:rPr>
-              <a:t>T</a:t>
+              <a:t>S</a:t>
             </a:r>
           </a:p>
         </p:txBody>
       </p:sp>
       <p:sp>
         <p:nvSpPr>
-          <p:cNvPr id="3" name="Oval 2">
+          <p:cNvPr id="14" name="Oval 13">
             <a:extLst>
               <a:ext uri="{FF2B5EF4-FFF2-40B4-BE49-F238E27FC236}">
-                <a16:creationId xmlns:a16="http://schemas.microsoft.com/office/drawing/2014/main" id="{F90431C2-B9D0-EAE7-9B3A-BA9CF469249F}"/>
+                <a16:creationId xmlns:a16="http://schemas.microsoft.com/office/drawing/2014/main" id="{2F5D9DBF-B00D-4CDF-B214-A340AABCC959}"/>
               </a:ext>
             </a:extLst>
           </p:cNvPr>
@@ -25845,7 +25765,7 @@
         </p:nvSpPr>
         <p:spPr bwMode="gray">
           <a:xfrm>
-            <a:off x="1482451" y="1388958"/>
+            <a:off x="4250686" y="1464375"/>
             <a:ext cx="914400" cy="914400"/>
           </a:xfrm>
           <a:prstGeom prst="ellipse">
@@ -25894,20 +25814,23 @@
             <a:r>
               <a:rPr lang="en-US" sz="2800" b="1" dirty="0">
                 <a:solidFill>
-                  <a:srgbClr val="BE2BBB"/>
+                  <a:schemeClr val="tx1">
+                    <a:lumMod val="40000"/>
+                    <a:lumOff val="60000"/>
+                  </a:schemeClr>
                 </a:solidFill>
               </a:rPr>
-              <a:t>S</a:t>
+              <a:t>W</a:t>
             </a:r>
           </a:p>
         </p:txBody>
       </p:sp>
       <p:sp>
         <p:nvSpPr>
-          <p:cNvPr id="5" name="Oval 4">
+          <p:cNvPr id="17" name="Oval 16">
             <a:extLst>
               <a:ext uri="{FF2B5EF4-FFF2-40B4-BE49-F238E27FC236}">
-                <a16:creationId xmlns:a16="http://schemas.microsoft.com/office/drawing/2014/main" id="{3804B353-F860-CA43-607D-6CF83F5CE96C}"/>
+                <a16:creationId xmlns:a16="http://schemas.microsoft.com/office/drawing/2014/main" id="{B9AC1357-B93E-452C-B362-E476BFE55558}"/>
               </a:ext>
             </a:extLst>
           </p:cNvPr>
@@ -25918,7 +25841,7 @@
         </p:nvSpPr>
         <p:spPr bwMode="gray">
           <a:xfrm>
-            <a:off x="4255318" y="1388958"/>
+            <a:off x="7022918" y="1464375"/>
             <a:ext cx="914400" cy="914400"/>
           </a:xfrm>
           <a:prstGeom prst="ellipse">
@@ -25967,20 +25890,20 @@
             <a:r>
               <a:rPr lang="en-US" sz="2800" b="1" dirty="0">
                 <a:solidFill>
-                  <a:srgbClr val="BE2BBB"/>
+                  <a:srgbClr val="0070C0"/>
                 </a:solidFill>
               </a:rPr>
-              <a:t>W</a:t>
+              <a:t>O</a:t>
             </a:r>
           </a:p>
         </p:txBody>
       </p:sp>
       <p:sp>
         <p:nvSpPr>
-          <p:cNvPr id="6" name="Oval 5">
+          <p:cNvPr id="20" name="Oval 19">
             <a:extLst>
               <a:ext uri="{FF2B5EF4-FFF2-40B4-BE49-F238E27FC236}">
-                <a16:creationId xmlns:a16="http://schemas.microsoft.com/office/drawing/2014/main" id="{D3D00735-C598-2703-BFAF-0F380A5392B3}"/>
+                <a16:creationId xmlns:a16="http://schemas.microsoft.com/office/drawing/2014/main" id="{9FD2B7FF-41D0-418B-A2FB-D0B9A979FBAD}"/>
               </a:ext>
             </a:extLst>
           </p:cNvPr>
@@ -25991,7 +25914,7 @@
         </p:nvSpPr>
         <p:spPr bwMode="gray">
           <a:xfrm>
-            <a:off x="7027550" y="1388958"/>
+            <a:off x="9795149" y="1464375"/>
             <a:ext cx="914400" cy="914400"/>
           </a:xfrm>
           <a:prstGeom prst="ellipse">
@@ -26040,10 +25963,10 @@
             <a:r>
               <a:rPr lang="en-US" sz="2800" b="1" dirty="0">
                 <a:solidFill>
-                  <a:srgbClr val="BE2BBB"/>
+                  <a:schemeClr val="tx1"/>
                 </a:solidFill>
               </a:rPr>
-              <a:t>O</a:t>
+              <a:t>T</a:t>
             </a:r>
           </a:p>
         </p:txBody>
@@ -26051,13 +25974,25 @@
     </p:spTree>
     <p:extLst>
       <p:ext uri="{BB962C8B-B14F-4D97-AF65-F5344CB8AC3E}">
-        <p14:creationId xmlns:p14="http://schemas.microsoft.com/office/powerpoint/2010/main" val="2943602238"/>
+        <p14:creationId xmlns:p14="http://schemas.microsoft.com/office/powerpoint/2010/main" val="3618675041"/>
       </p:ext>
     </p:extLst>
   </p:cSld>
   <p:clrMapOvr>
     <a:masterClrMapping/>
   </p:clrMapOvr>
+  <mc:AlternateContent xmlns:mc="http://schemas.openxmlformats.org/markup-compatibility/2006" xmlns:p14="http://schemas.microsoft.com/office/powerpoint/2010/main">
+    <mc:Choice Requires="p14">
+      <p:transition spd="med" p14:dur="700">
+        <p:fade/>
+      </p:transition>
+    </mc:Choice>
+    <mc:Fallback xmlns="">
+      <p:transition spd="med">
+        <p:fade/>
+      </p:transition>
+    </mc:Fallback>
+  </mc:AlternateContent>
 </p:sld>
 </file>
 
@@ -26186,13 +26121,13 @@
   <p:clrMapOvr>
     <a:masterClrMapping/>
   </p:clrMapOvr>
-  <mc:AlternateContent xmlns:mc="http://schemas.openxmlformats.org/markup-compatibility/2006">
-    <mc:Choice xmlns:p14="http://schemas.microsoft.com/office/powerpoint/2010/main" Requires="p14">
+  <mc:AlternateContent xmlns:mc="http://schemas.openxmlformats.org/markup-compatibility/2006" xmlns:p14="http://schemas.microsoft.com/office/powerpoint/2010/main">
+    <mc:Choice Requires="p14">
       <p:transition spd="med" p14:dur="700">
         <p:fade/>
       </p:transition>
     </mc:Choice>
-    <mc:Fallback>
+    <mc:Fallback xmlns="">
       <p:transition spd="med">
         <p:fade/>
       </p:transition>
@@ -28371,21 +28306,12 @@
 </file>
 
 <file path=customXml/item1.xml><?xml version="1.0" encoding="utf-8"?>
-<p:properties xmlns:p="http://schemas.microsoft.com/office/2006/metadata/properties" xmlns:xsi="http://www.w3.org/2001/XMLSchema-instance" xmlns:pc="http://schemas.microsoft.com/office/infopath/2007/PartnerControls">
-  <documentManagement>
-    <TaxCatchAll xmlns="1ff81937-46f0-48f5-a4f4-7207cfde9880" xsi:nil="true"/>
-    <SharedWithUsers xmlns="1ff81937-46f0-48f5-a4f4-7207cfde9880">
-      <UserInfo>
-        <DisplayName>Kaplan, Lori</DisplayName>
-        <AccountId>27</AccountId>
-        <AccountType/>
-      </UserInfo>
-    </SharedWithUsers>
-    <lcf76f155ced4ddcb4097134ff3c332f xmlns="d58aa00e-f3c0-46ab-a6c5-a4aa8ec7276e">
-      <Terms xmlns="http://schemas.microsoft.com/office/infopath/2007/PartnerControls"/>
-    </lcf76f155ced4ddcb4097134ff3c332f>
-  </documentManagement>
-</p:properties>
+<?mso-contentType ?>
+<FormTemplates xmlns="http://schemas.microsoft.com/sharepoint/v3/contenttype/forms">
+  <Display>DocumentLibraryForm</Display>
+  <Edit>DocumentLibraryForm</Edit>
+  <New>DocumentLibraryForm</New>
+</FormTemplates>
 </file>
 
 <file path=customXml/item2.xml><?xml version="1.0" encoding="utf-8"?>
@@ -28610,28 +28536,27 @@
 </file>
 
 <file path=customXml/item3.xml><?xml version="1.0" encoding="utf-8"?>
-<?mso-contentType ?>
-<FormTemplates xmlns="http://schemas.microsoft.com/sharepoint/v3/contenttype/forms">
-  <Display>DocumentLibraryForm</Display>
-  <Edit>DocumentLibraryForm</Edit>
-  <New>DocumentLibraryForm</New>
-</FormTemplates>
+<p:properties xmlns:p="http://schemas.microsoft.com/office/2006/metadata/properties" xmlns:xsi="http://www.w3.org/2001/XMLSchema-instance" xmlns:pc="http://schemas.microsoft.com/office/infopath/2007/PartnerControls">
+  <documentManagement>
+    <TaxCatchAll xmlns="1ff81937-46f0-48f5-a4f4-7207cfde9880" xsi:nil="true"/>
+    <SharedWithUsers xmlns="1ff81937-46f0-48f5-a4f4-7207cfde9880">
+      <UserInfo>
+        <DisplayName>Kaplan, Lori</DisplayName>
+        <AccountId>27</AccountId>
+        <AccountType/>
+      </UserInfo>
+    </SharedWithUsers>
+    <lcf76f155ced4ddcb4097134ff3c332f xmlns="d58aa00e-f3c0-46ab-a6c5-a4aa8ec7276e">
+      <Terms xmlns="http://schemas.microsoft.com/office/infopath/2007/PartnerControls"/>
+    </lcf76f155ced4ddcb4097134ff3c332f>
+  </documentManagement>
+</p:properties>
 </file>
 
 <file path=customXml/itemProps1.xml><?xml version="1.0" encoding="utf-8"?>
-<ds:datastoreItem xmlns:ds="http://schemas.openxmlformats.org/officeDocument/2006/customXml" ds:itemID="{6B059CB1-CB57-45C8-B58C-EB9957E73A5D}">
+<ds:datastoreItem xmlns:ds="http://schemas.openxmlformats.org/officeDocument/2006/customXml" ds:itemID="{A2F406D8-50A4-457E-B611-78758F79527B}">
   <ds:schemaRefs>
-    <ds:schemaRef ds:uri="1ff81937-46f0-48f5-a4f4-7207cfde9880"/>
-    <ds:schemaRef ds:uri="4ce1936b-43e3-436c-964a-a212a0edf4f1"/>
-    <ds:schemaRef ds:uri="d58aa00e-f3c0-46ab-a6c5-a4aa8ec7276e"/>
-    <ds:schemaRef ds:uri="http://purl.org/dc/dcmitype/"/>
-    <ds:schemaRef ds:uri="http://purl.org/dc/elements/1.1/"/>
-    <ds:schemaRef ds:uri="http://purl.org/dc/terms/"/>
-    <ds:schemaRef ds:uri="http://schemas.microsoft.com/office/2006/documentManagement/types"/>
-    <ds:schemaRef ds:uri="http://schemas.microsoft.com/office/2006/metadata/properties"/>
-    <ds:schemaRef ds:uri="http://schemas.microsoft.com/office/infopath/2007/PartnerControls"/>
-    <ds:schemaRef ds:uri="http://schemas.openxmlformats.org/package/2006/metadata/core-properties"/>
-    <ds:schemaRef ds:uri="http://www.w3.org/XML/1998/namespace"/>
+    <ds:schemaRef ds:uri="http://schemas.microsoft.com/sharepoint/v3/contenttype/forms"/>
   </ds:schemaRefs>
 </ds:datastoreItem>
 </file>
@@ -28656,9 +28581,19 @@
 </file>
 
 <file path=customXml/itemProps3.xml><?xml version="1.0" encoding="utf-8"?>
-<ds:datastoreItem xmlns:ds="http://schemas.openxmlformats.org/officeDocument/2006/customXml" ds:itemID="{A2F406D8-50A4-457E-B611-78758F79527B}">
+<ds:datastoreItem xmlns:ds="http://schemas.openxmlformats.org/officeDocument/2006/customXml" ds:itemID="{6B059CB1-CB57-45C8-B58C-EB9957E73A5D}">
   <ds:schemaRefs>
-    <ds:schemaRef ds:uri="http://schemas.microsoft.com/sharepoint/v3/contenttype/forms"/>
+    <ds:schemaRef ds:uri="1ff81937-46f0-48f5-a4f4-7207cfde9880"/>
+    <ds:schemaRef ds:uri="4ce1936b-43e3-436c-964a-a212a0edf4f1"/>
+    <ds:schemaRef ds:uri="d58aa00e-f3c0-46ab-a6c5-a4aa8ec7276e"/>
+    <ds:schemaRef ds:uri="http://purl.org/dc/dcmitype/"/>
+    <ds:schemaRef ds:uri="http://purl.org/dc/elements/1.1/"/>
+    <ds:schemaRef ds:uri="http://purl.org/dc/terms/"/>
+    <ds:schemaRef ds:uri="http://schemas.microsoft.com/office/2006/documentManagement/types"/>
+    <ds:schemaRef ds:uri="http://schemas.microsoft.com/office/2006/metadata/properties"/>
+    <ds:schemaRef ds:uri="http://schemas.microsoft.com/office/infopath/2007/PartnerControls"/>
+    <ds:schemaRef ds:uri="http://schemas.openxmlformats.org/package/2006/metadata/core-properties"/>
+    <ds:schemaRef ds:uri="http://www.w3.org/XML/1998/namespace"/>
   </ds:schemaRefs>
 </ds:datastoreItem>
 </file>

</xml_diff>